<commit_message>
feat: link official Sethcon Company Profile (Google Drive) and tailor narrative to Lay Bare custom payroll partnership in presentation and app
</commit_message>
<xml_diff>
--- a/ALRAJJ_LEGACY_Payroll_Demo_Presentation.pptx
+++ b/ALRAJJ_LEGACY_Payroll_Demo_Presentation.pptx
@@ -137,7 +137,7 @@
           <p:cNvPr id="2" name="Title 1">
             <a:extLst>
               <a:ext uri="{FF2B5EF4-FFF2-40B4-BE49-F238E27FC236}">
-                <a16:creationId xmlns:a16="http://schemas.microsoft.com/office/drawing/2014/main" id="{0C47577E-42CA-E34F-CA76-80EDF8B480B9}"/>
+                <a16:creationId xmlns:a16="http://schemas.microsoft.com/office/drawing/2014/main" id="{C2074684-36F3-445A-EB86-E92D07D30C58}"/>
               </a:ext>
             </a:extLst>
           </p:cNvPr>
@@ -174,7 +174,7 @@
           <p:cNvPr id="3" name="Subtitle 2">
             <a:extLst>
               <a:ext uri="{FF2B5EF4-FFF2-40B4-BE49-F238E27FC236}">
-                <a16:creationId xmlns:a16="http://schemas.microsoft.com/office/drawing/2014/main" id="{293EAED4-61EA-F597-8091-338DF05D004A}"/>
+                <a16:creationId xmlns:a16="http://schemas.microsoft.com/office/drawing/2014/main" id="{54AFC46C-B943-FDE0-BD96-68F1F12234A3}"/>
               </a:ext>
             </a:extLst>
           </p:cNvPr>
@@ -244,7 +244,7 @@
           <p:cNvPr id="4" name="Date Placeholder 3">
             <a:extLst>
               <a:ext uri="{FF2B5EF4-FFF2-40B4-BE49-F238E27FC236}">
-                <a16:creationId xmlns:a16="http://schemas.microsoft.com/office/drawing/2014/main" id="{4961C64A-D7D5-7C2C-6478-F2F4EC93AE81}"/>
+                <a16:creationId xmlns:a16="http://schemas.microsoft.com/office/drawing/2014/main" id="{8BC7E39F-E51F-1E0A-F81C-6B21359B94DF}"/>
               </a:ext>
             </a:extLst>
           </p:cNvPr>
@@ -260,9 +260,9 @@
           <a:bodyPr/>
           <a:lstStyle/>
           <a:p>
-            <a:fld id="{B1BDA628-8D64-4EDE-A986-760E78C72F76}" type="datetimeFigureOut">
+            <a:fld id="{722BF64C-CFE5-49BD-854E-797BD1FC74DB}" type="datetimeFigureOut">
               <a:rPr lang="en-US" smtClean="0"/>
-              <a:t>9/7/2026</a:t>
+              <a:t>9/8/2026</a:t>
             </a:fld>
             <a:endParaRPr lang="en-US"/>
           </a:p>
@@ -273,7 +273,7 @@
           <p:cNvPr id="5" name="Footer Placeholder 4">
             <a:extLst>
               <a:ext uri="{FF2B5EF4-FFF2-40B4-BE49-F238E27FC236}">
-                <a16:creationId xmlns:a16="http://schemas.microsoft.com/office/drawing/2014/main" id="{8311FCCD-0E9E-2465-14F0-7B9A06E7FD5A}"/>
+                <a16:creationId xmlns:a16="http://schemas.microsoft.com/office/drawing/2014/main" id="{A483FDAC-2B68-FFF2-AD23-42BB2BAFE3F2}"/>
               </a:ext>
             </a:extLst>
           </p:cNvPr>
@@ -298,7 +298,7 @@
           <p:cNvPr id="6" name="Slide Number Placeholder 5">
             <a:extLst>
               <a:ext uri="{FF2B5EF4-FFF2-40B4-BE49-F238E27FC236}">
-                <a16:creationId xmlns:a16="http://schemas.microsoft.com/office/drawing/2014/main" id="{FC1D72BF-E3AE-08B5-BF57-0057FFBD1172}"/>
+                <a16:creationId xmlns:a16="http://schemas.microsoft.com/office/drawing/2014/main" id="{ABE02BC6-76F1-29BE-C7DE-2CD7C610EDC8}"/>
               </a:ext>
             </a:extLst>
           </p:cNvPr>
@@ -314,7 +314,7 @@
           <a:bodyPr/>
           <a:lstStyle/>
           <a:p>
-            <a:fld id="{AE1BC162-5E59-493F-B0A3-6CDD71436CB9}" type="slidenum">
+            <a:fld id="{CBD6D984-39C0-49BD-A2E8-444D556E25F0}" type="slidenum">
               <a:rPr lang="en-US" smtClean="0"/>
               <a:t>‹#›</a:t>
             </a:fld>
@@ -325,7 +325,7 @@
     </p:spTree>
     <p:extLst>
       <p:ext uri="{BB962C8B-B14F-4D97-AF65-F5344CB8AC3E}">
-        <p14:creationId xmlns:p14="http://schemas.microsoft.com/office/powerpoint/2010/main" val="1182691465"/>
+        <p14:creationId xmlns:p14="http://schemas.microsoft.com/office/powerpoint/2010/main" val="1215420449"/>
       </p:ext>
     </p:extLst>
   </p:cSld>
@@ -357,7 +357,7 @@
           <p:cNvPr id="2" name="Title 1">
             <a:extLst>
               <a:ext uri="{FF2B5EF4-FFF2-40B4-BE49-F238E27FC236}">
-                <a16:creationId xmlns:a16="http://schemas.microsoft.com/office/drawing/2014/main" id="{10C90F62-6147-9CB3-A361-FF03680E0361}"/>
+                <a16:creationId xmlns:a16="http://schemas.microsoft.com/office/drawing/2014/main" id="{72541486-912E-D152-C878-7D3CCB94C724}"/>
               </a:ext>
             </a:extLst>
           </p:cNvPr>
@@ -385,7 +385,7 @@
           <p:cNvPr id="3" name="Vertical Text Placeholder 2">
             <a:extLst>
               <a:ext uri="{FF2B5EF4-FFF2-40B4-BE49-F238E27FC236}">
-                <a16:creationId xmlns:a16="http://schemas.microsoft.com/office/drawing/2014/main" id="{3F444B08-D137-FFAA-B819-089267B96C34}"/>
+                <a16:creationId xmlns:a16="http://schemas.microsoft.com/office/drawing/2014/main" id="{48F64B9E-1E4A-9809-BB03-7099061429F9}"/>
               </a:ext>
             </a:extLst>
           </p:cNvPr>
@@ -442,7 +442,7 @@
           <p:cNvPr id="4" name="Date Placeholder 3">
             <a:extLst>
               <a:ext uri="{FF2B5EF4-FFF2-40B4-BE49-F238E27FC236}">
-                <a16:creationId xmlns:a16="http://schemas.microsoft.com/office/drawing/2014/main" id="{3A49ADB7-FA12-8728-931A-77781FC82571}"/>
+                <a16:creationId xmlns:a16="http://schemas.microsoft.com/office/drawing/2014/main" id="{AE6E414E-1ED5-836D-28CB-CE833502D043}"/>
               </a:ext>
             </a:extLst>
           </p:cNvPr>
@@ -458,9 +458,9 @@
           <a:bodyPr/>
           <a:lstStyle/>
           <a:p>
-            <a:fld id="{B1BDA628-8D64-4EDE-A986-760E78C72F76}" type="datetimeFigureOut">
+            <a:fld id="{722BF64C-CFE5-49BD-854E-797BD1FC74DB}" type="datetimeFigureOut">
               <a:rPr lang="en-US" smtClean="0"/>
-              <a:t>9/7/2026</a:t>
+              <a:t>9/8/2026</a:t>
             </a:fld>
             <a:endParaRPr lang="en-US"/>
           </a:p>
@@ -471,7 +471,7 @@
           <p:cNvPr id="5" name="Footer Placeholder 4">
             <a:extLst>
               <a:ext uri="{FF2B5EF4-FFF2-40B4-BE49-F238E27FC236}">
-                <a16:creationId xmlns:a16="http://schemas.microsoft.com/office/drawing/2014/main" id="{8988CEF3-E526-60D1-8A88-38CC0BF08E3B}"/>
+                <a16:creationId xmlns:a16="http://schemas.microsoft.com/office/drawing/2014/main" id="{EDAF0E24-3170-7FB5-608F-629A46031AF8}"/>
               </a:ext>
             </a:extLst>
           </p:cNvPr>
@@ -496,7 +496,7 @@
           <p:cNvPr id="6" name="Slide Number Placeholder 5">
             <a:extLst>
               <a:ext uri="{FF2B5EF4-FFF2-40B4-BE49-F238E27FC236}">
-                <a16:creationId xmlns:a16="http://schemas.microsoft.com/office/drawing/2014/main" id="{A2EC5730-950B-2874-E0BA-AFA7D95EA47F}"/>
+                <a16:creationId xmlns:a16="http://schemas.microsoft.com/office/drawing/2014/main" id="{ECDE4494-8059-2B19-81ED-B59F145E7297}"/>
               </a:ext>
             </a:extLst>
           </p:cNvPr>
@@ -512,7 +512,7 @@
           <a:bodyPr/>
           <a:lstStyle/>
           <a:p>
-            <a:fld id="{AE1BC162-5E59-493F-B0A3-6CDD71436CB9}" type="slidenum">
+            <a:fld id="{CBD6D984-39C0-49BD-A2E8-444D556E25F0}" type="slidenum">
               <a:rPr lang="en-US" smtClean="0"/>
               <a:t>‹#›</a:t>
             </a:fld>
@@ -523,7 +523,7 @@
     </p:spTree>
     <p:extLst>
       <p:ext uri="{BB962C8B-B14F-4D97-AF65-F5344CB8AC3E}">
-        <p14:creationId xmlns:p14="http://schemas.microsoft.com/office/powerpoint/2010/main" val="3499819996"/>
+        <p14:creationId xmlns:p14="http://schemas.microsoft.com/office/powerpoint/2010/main" val="363310859"/>
       </p:ext>
     </p:extLst>
   </p:cSld>
@@ -555,7 +555,7 @@
           <p:cNvPr id="2" name="Vertical Title 1">
             <a:extLst>
               <a:ext uri="{FF2B5EF4-FFF2-40B4-BE49-F238E27FC236}">
-                <a16:creationId xmlns:a16="http://schemas.microsoft.com/office/drawing/2014/main" id="{DF58D354-43C3-2A0F-2E1E-1A71066E3830}"/>
+                <a16:creationId xmlns:a16="http://schemas.microsoft.com/office/drawing/2014/main" id="{B77E9FDF-09CD-160F-35E6-7F134BFD9ACC}"/>
               </a:ext>
             </a:extLst>
           </p:cNvPr>
@@ -588,7 +588,7 @@
           <p:cNvPr id="3" name="Vertical Text Placeholder 2">
             <a:extLst>
               <a:ext uri="{FF2B5EF4-FFF2-40B4-BE49-F238E27FC236}">
-                <a16:creationId xmlns:a16="http://schemas.microsoft.com/office/drawing/2014/main" id="{3E5EED9B-D790-FB79-910F-FA0A93E32EE6}"/>
+                <a16:creationId xmlns:a16="http://schemas.microsoft.com/office/drawing/2014/main" id="{170D7804-B408-1F7F-4C3C-E4A8B25CFA0C}"/>
               </a:ext>
             </a:extLst>
           </p:cNvPr>
@@ -650,7 +650,7 @@
           <p:cNvPr id="4" name="Date Placeholder 3">
             <a:extLst>
               <a:ext uri="{FF2B5EF4-FFF2-40B4-BE49-F238E27FC236}">
-                <a16:creationId xmlns:a16="http://schemas.microsoft.com/office/drawing/2014/main" id="{AC24638E-F9CC-FDEE-82FD-DE52A1D34BD2}"/>
+                <a16:creationId xmlns:a16="http://schemas.microsoft.com/office/drawing/2014/main" id="{7E247763-D8E6-23BD-69B4-6176001BA361}"/>
               </a:ext>
             </a:extLst>
           </p:cNvPr>
@@ -666,9 +666,9 @@
           <a:bodyPr/>
           <a:lstStyle/>
           <a:p>
-            <a:fld id="{B1BDA628-8D64-4EDE-A986-760E78C72F76}" type="datetimeFigureOut">
+            <a:fld id="{722BF64C-CFE5-49BD-854E-797BD1FC74DB}" type="datetimeFigureOut">
               <a:rPr lang="en-US" smtClean="0"/>
-              <a:t>9/7/2026</a:t>
+              <a:t>9/8/2026</a:t>
             </a:fld>
             <a:endParaRPr lang="en-US"/>
           </a:p>
@@ -679,7 +679,7 @@
           <p:cNvPr id="5" name="Footer Placeholder 4">
             <a:extLst>
               <a:ext uri="{FF2B5EF4-FFF2-40B4-BE49-F238E27FC236}">
-                <a16:creationId xmlns:a16="http://schemas.microsoft.com/office/drawing/2014/main" id="{02F7EBC5-8EA5-312E-3109-A7A040715F7F}"/>
+                <a16:creationId xmlns:a16="http://schemas.microsoft.com/office/drawing/2014/main" id="{14199E4A-E7D0-EED4-D36D-9C6D635D6571}"/>
               </a:ext>
             </a:extLst>
           </p:cNvPr>
@@ -704,7 +704,7 @@
           <p:cNvPr id="6" name="Slide Number Placeholder 5">
             <a:extLst>
               <a:ext uri="{FF2B5EF4-FFF2-40B4-BE49-F238E27FC236}">
-                <a16:creationId xmlns:a16="http://schemas.microsoft.com/office/drawing/2014/main" id="{A0375CEF-0C72-6957-0151-58B8504414D9}"/>
+                <a16:creationId xmlns:a16="http://schemas.microsoft.com/office/drawing/2014/main" id="{262FA6DD-4867-8B9A-4F4B-9AC43A2786B4}"/>
               </a:ext>
             </a:extLst>
           </p:cNvPr>
@@ -720,7 +720,7 @@
           <a:bodyPr/>
           <a:lstStyle/>
           <a:p>
-            <a:fld id="{AE1BC162-5E59-493F-B0A3-6CDD71436CB9}" type="slidenum">
+            <a:fld id="{CBD6D984-39C0-49BD-A2E8-444D556E25F0}" type="slidenum">
               <a:rPr lang="en-US" smtClean="0"/>
               <a:t>‹#›</a:t>
             </a:fld>
@@ -731,7 +731,7 @@
     </p:spTree>
     <p:extLst>
       <p:ext uri="{BB962C8B-B14F-4D97-AF65-F5344CB8AC3E}">
-        <p14:creationId xmlns:p14="http://schemas.microsoft.com/office/powerpoint/2010/main" val="811076875"/>
+        <p14:creationId xmlns:p14="http://schemas.microsoft.com/office/powerpoint/2010/main" val="3130827921"/>
       </p:ext>
     </p:extLst>
   </p:cSld>
@@ -763,7 +763,7 @@
           <p:cNvPr id="2" name="Title 1">
             <a:extLst>
               <a:ext uri="{FF2B5EF4-FFF2-40B4-BE49-F238E27FC236}">
-                <a16:creationId xmlns:a16="http://schemas.microsoft.com/office/drawing/2014/main" id="{0051F9C9-6829-CE03-C5E2-A99914300BE6}"/>
+                <a16:creationId xmlns:a16="http://schemas.microsoft.com/office/drawing/2014/main" id="{DEF30E24-C258-E8AC-8AC1-536914A3F65A}"/>
               </a:ext>
             </a:extLst>
           </p:cNvPr>
@@ -791,7 +791,7 @@
           <p:cNvPr id="3" name="Content Placeholder 2">
             <a:extLst>
               <a:ext uri="{FF2B5EF4-FFF2-40B4-BE49-F238E27FC236}">
-                <a16:creationId xmlns:a16="http://schemas.microsoft.com/office/drawing/2014/main" id="{D1090B3D-8785-37B1-02D8-0510F617C452}"/>
+                <a16:creationId xmlns:a16="http://schemas.microsoft.com/office/drawing/2014/main" id="{2E5477D8-3CD3-0C5A-A0B8-C5844ACF3A94}"/>
               </a:ext>
             </a:extLst>
           </p:cNvPr>
@@ -848,7 +848,7 @@
           <p:cNvPr id="4" name="Date Placeholder 3">
             <a:extLst>
               <a:ext uri="{FF2B5EF4-FFF2-40B4-BE49-F238E27FC236}">
-                <a16:creationId xmlns:a16="http://schemas.microsoft.com/office/drawing/2014/main" id="{DE8F9F59-5B3F-6178-5426-7FFD148959B3}"/>
+                <a16:creationId xmlns:a16="http://schemas.microsoft.com/office/drawing/2014/main" id="{2FF29197-EFA4-618E-690C-5B4B51A2B688}"/>
               </a:ext>
             </a:extLst>
           </p:cNvPr>
@@ -864,9 +864,9 @@
           <a:bodyPr/>
           <a:lstStyle/>
           <a:p>
-            <a:fld id="{B1BDA628-8D64-4EDE-A986-760E78C72F76}" type="datetimeFigureOut">
+            <a:fld id="{722BF64C-CFE5-49BD-854E-797BD1FC74DB}" type="datetimeFigureOut">
               <a:rPr lang="en-US" smtClean="0"/>
-              <a:t>9/7/2026</a:t>
+              <a:t>9/8/2026</a:t>
             </a:fld>
             <a:endParaRPr lang="en-US"/>
           </a:p>
@@ -877,7 +877,7 @@
           <p:cNvPr id="5" name="Footer Placeholder 4">
             <a:extLst>
               <a:ext uri="{FF2B5EF4-FFF2-40B4-BE49-F238E27FC236}">
-                <a16:creationId xmlns:a16="http://schemas.microsoft.com/office/drawing/2014/main" id="{54B2C533-1E6E-3AAF-29AA-1EC9EE357A54}"/>
+                <a16:creationId xmlns:a16="http://schemas.microsoft.com/office/drawing/2014/main" id="{99ECAE12-C219-07C8-FD0C-8EDB91D17590}"/>
               </a:ext>
             </a:extLst>
           </p:cNvPr>
@@ -902,7 +902,7 @@
           <p:cNvPr id="6" name="Slide Number Placeholder 5">
             <a:extLst>
               <a:ext uri="{FF2B5EF4-FFF2-40B4-BE49-F238E27FC236}">
-                <a16:creationId xmlns:a16="http://schemas.microsoft.com/office/drawing/2014/main" id="{E2A2B617-B23B-493D-8AD2-0F7F23FC21D9}"/>
+                <a16:creationId xmlns:a16="http://schemas.microsoft.com/office/drawing/2014/main" id="{FBE8BF62-CDF3-BE6D-DF3F-6BC7A22BAB34}"/>
               </a:ext>
             </a:extLst>
           </p:cNvPr>
@@ -918,7 +918,7 @@
           <a:bodyPr/>
           <a:lstStyle/>
           <a:p>
-            <a:fld id="{AE1BC162-5E59-493F-B0A3-6CDD71436CB9}" type="slidenum">
+            <a:fld id="{CBD6D984-39C0-49BD-A2E8-444D556E25F0}" type="slidenum">
               <a:rPr lang="en-US" smtClean="0"/>
               <a:t>‹#›</a:t>
             </a:fld>
@@ -929,7 +929,7 @@
     </p:spTree>
     <p:extLst>
       <p:ext uri="{BB962C8B-B14F-4D97-AF65-F5344CB8AC3E}">
-        <p14:creationId xmlns:p14="http://schemas.microsoft.com/office/powerpoint/2010/main" val="250197346"/>
+        <p14:creationId xmlns:p14="http://schemas.microsoft.com/office/powerpoint/2010/main" val="448108174"/>
       </p:ext>
     </p:extLst>
   </p:cSld>
@@ -961,7 +961,7 @@
           <p:cNvPr id="2" name="Title 1">
             <a:extLst>
               <a:ext uri="{FF2B5EF4-FFF2-40B4-BE49-F238E27FC236}">
-                <a16:creationId xmlns:a16="http://schemas.microsoft.com/office/drawing/2014/main" id="{801BE044-A4DD-0C5D-9469-49CF25D6C00A}"/>
+                <a16:creationId xmlns:a16="http://schemas.microsoft.com/office/drawing/2014/main" id="{7427500D-AC87-124E-6D9E-6EB5C24E44AA}"/>
               </a:ext>
             </a:extLst>
           </p:cNvPr>
@@ -998,7 +998,7 @@
           <p:cNvPr id="3" name="Text Placeholder 2">
             <a:extLst>
               <a:ext uri="{FF2B5EF4-FFF2-40B4-BE49-F238E27FC236}">
-                <a16:creationId xmlns:a16="http://schemas.microsoft.com/office/drawing/2014/main" id="{FCE8BC26-F30B-8A5F-27C6-080424C60FC0}"/>
+                <a16:creationId xmlns:a16="http://schemas.microsoft.com/office/drawing/2014/main" id="{70A57E35-86E6-1A8F-364D-F97C74ECEAE0}"/>
               </a:ext>
             </a:extLst>
           </p:cNvPr>
@@ -1123,7 +1123,7 @@
           <p:cNvPr id="4" name="Date Placeholder 3">
             <a:extLst>
               <a:ext uri="{FF2B5EF4-FFF2-40B4-BE49-F238E27FC236}">
-                <a16:creationId xmlns:a16="http://schemas.microsoft.com/office/drawing/2014/main" id="{3DF71A02-3852-80A4-38B6-8EB47D26A392}"/>
+                <a16:creationId xmlns:a16="http://schemas.microsoft.com/office/drawing/2014/main" id="{1B02FDDE-5307-C14D-55BE-0DB4F965500B}"/>
               </a:ext>
             </a:extLst>
           </p:cNvPr>
@@ -1139,9 +1139,9 @@
           <a:bodyPr/>
           <a:lstStyle/>
           <a:p>
-            <a:fld id="{B1BDA628-8D64-4EDE-A986-760E78C72F76}" type="datetimeFigureOut">
+            <a:fld id="{722BF64C-CFE5-49BD-854E-797BD1FC74DB}" type="datetimeFigureOut">
               <a:rPr lang="en-US" smtClean="0"/>
-              <a:t>9/7/2026</a:t>
+              <a:t>9/8/2026</a:t>
             </a:fld>
             <a:endParaRPr lang="en-US"/>
           </a:p>
@@ -1152,7 +1152,7 @@
           <p:cNvPr id="5" name="Footer Placeholder 4">
             <a:extLst>
               <a:ext uri="{FF2B5EF4-FFF2-40B4-BE49-F238E27FC236}">
-                <a16:creationId xmlns:a16="http://schemas.microsoft.com/office/drawing/2014/main" id="{E0304DE3-AC65-7E89-FA55-06E489BD6F6E}"/>
+                <a16:creationId xmlns:a16="http://schemas.microsoft.com/office/drawing/2014/main" id="{B0638BA7-3534-DC0B-1784-61225F2E42C5}"/>
               </a:ext>
             </a:extLst>
           </p:cNvPr>
@@ -1177,7 +1177,7 @@
           <p:cNvPr id="6" name="Slide Number Placeholder 5">
             <a:extLst>
               <a:ext uri="{FF2B5EF4-FFF2-40B4-BE49-F238E27FC236}">
-                <a16:creationId xmlns:a16="http://schemas.microsoft.com/office/drawing/2014/main" id="{ADDC8F69-6FCC-EF60-0585-08A0BB51D429}"/>
+                <a16:creationId xmlns:a16="http://schemas.microsoft.com/office/drawing/2014/main" id="{D7ACFF65-87E6-249F-95F4-94D7E8F600F8}"/>
               </a:ext>
             </a:extLst>
           </p:cNvPr>
@@ -1193,7 +1193,7 @@
           <a:bodyPr/>
           <a:lstStyle/>
           <a:p>
-            <a:fld id="{AE1BC162-5E59-493F-B0A3-6CDD71436CB9}" type="slidenum">
+            <a:fld id="{CBD6D984-39C0-49BD-A2E8-444D556E25F0}" type="slidenum">
               <a:rPr lang="en-US" smtClean="0"/>
               <a:t>‹#›</a:t>
             </a:fld>
@@ -1204,7 +1204,7 @@
     </p:spTree>
     <p:extLst>
       <p:ext uri="{BB962C8B-B14F-4D97-AF65-F5344CB8AC3E}">
-        <p14:creationId xmlns:p14="http://schemas.microsoft.com/office/powerpoint/2010/main" val="2781065106"/>
+        <p14:creationId xmlns:p14="http://schemas.microsoft.com/office/powerpoint/2010/main" val="2088989572"/>
       </p:ext>
     </p:extLst>
   </p:cSld>
@@ -1236,7 +1236,7 @@
           <p:cNvPr id="2" name="Title 1">
             <a:extLst>
               <a:ext uri="{FF2B5EF4-FFF2-40B4-BE49-F238E27FC236}">
-                <a16:creationId xmlns:a16="http://schemas.microsoft.com/office/drawing/2014/main" id="{F799B23F-3504-0412-43B2-9FEAF008C8E0}"/>
+                <a16:creationId xmlns:a16="http://schemas.microsoft.com/office/drawing/2014/main" id="{AB6E9138-EA24-5846-812A-C6414A37096A}"/>
               </a:ext>
             </a:extLst>
           </p:cNvPr>
@@ -1264,7 +1264,7 @@
           <p:cNvPr id="3" name="Content Placeholder 2">
             <a:extLst>
               <a:ext uri="{FF2B5EF4-FFF2-40B4-BE49-F238E27FC236}">
-                <a16:creationId xmlns:a16="http://schemas.microsoft.com/office/drawing/2014/main" id="{51642A3F-A76B-2AC0-4845-C90DC8F18F2F}"/>
+                <a16:creationId xmlns:a16="http://schemas.microsoft.com/office/drawing/2014/main" id="{506B081C-04DB-B044-F377-8345B6259DDE}"/>
               </a:ext>
             </a:extLst>
           </p:cNvPr>
@@ -1326,7 +1326,7 @@
           <p:cNvPr id="4" name="Content Placeholder 3">
             <a:extLst>
               <a:ext uri="{FF2B5EF4-FFF2-40B4-BE49-F238E27FC236}">
-                <a16:creationId xmlns:a16="http://schemas.microsoft.com/office/drawing/2014/main" id="{A64A6967-28BC-6C08-9DC2-8A7150C4E398}"/>
+                <a16:creationId xmlns:a16="http://schemas.microsoft.com/office/drawing/2014/main" id="{80C2AD76-8CB4-AFAB-BF7D-762718EA24DB}"/>
               </a:ext>
             </a:extLst>
           </p:cNvPr>
@@ -1388,7 +1388,7 @@
           <p:cNvPr id="5" name="Date Placeholder 4">
             <a:extLst>
               <a:ext uri="{FF2B5EF4-FFF2-40B4-BE49-F238E27FC236}">
-                <a16:creationId xmlns:a16="http://schemas.microsoft.com/office/drawing/2014/main" id="{4A48D2A1-8488-7892-D55F-CF48B6650EFB}"/>
+                <a16:creationId xmlns:a16="http://schemas.microsoft.com/office/drawing/2014/main" id="{E7957FD3-FA9B-CEEC-D3B0-6202D26E72AD}"/>
               </a:ext>
             </a:extLst>
           </p:cNvPr>
@@ -1404,9 +1404,9 @@
           <a:bodyPr/>
           <a:lstStyle/>
           <a:p>
-            <a:fld id="{B1BDA628-8D64-4EDE-A986-760E78C72F76}" type="datetimeFigureOut">
+            <a:fld id="{722BF64C-CFE5-49BD-854E-797BD1FC74DB}" type="datetimeFigureOut">
               <a:rPr lang="en-US" smtClean="0"/>
-              <a:t>9/7/2026</a:t>
+              <a:t>9/8/2026</a:t>
             </a:fld>
             <a:endParaRPr lang="en-US"/>
           </a:p>
@@ -1417,7 +1417,7 @@
           <p:cNvPr id="6" name="Footer Placeholder 5">
             <a:extLst>
               <a:ext uri="{FF2B5EF4-FFF2-40B4-BE49-F238E27FC236}">
-                <a16:creationId xmlns:a16="http://schemas.microsoft.com/office/drawing/2014/main" id="{0C98D936-ED82-52BB-259E-C2E280B9A0EC}"/>
+                <a16:creationId xmlns:a16="http://schemas.microsoft.com/office/drawing/2014/main" id="{628F9325-75D6-A648-4682-AFEE86183CBD}"/>
               </a:ext>
             </a:extLst>
           </p:cNvPr>
@@ -1442,7 +1442,7 @@
           <p:cNvPr id="7" name="Slide Number Placeholder 6">
             <a:extLst>
               <a:ext uri="{FF2B5EF4-FFF2-40B4-BE49-F238E27FC236}">
-                <a16:creationId xmlns:a16="http://schemas.microsoft.com/office/drawing/2014/main" id="{3ED33CEA-96EB-A02A-F62C-4DF6A5E85FF6}"/>
+                <a16:creationId xmlns:a16="http://schemas.microsoft.com/office/drawing/2014/main" id="{8F08B543-9969-6512-A85D-66BCD31D6854}"/>
               </a:ext>
             </a:extLst>
           </p:cNvPr>
@@ -1458,7 +1458,7 @@
           <a:bodyPr/>
           <a:lstStyle/>
           <a:p>
-            <a:fld id="{AE1BC162-5E59-493F-B0A3-6CDD71436CB9}" type="slidenum">
+            <a:fld id="{CBD6D984-39C0-49BD-A2E8-444D556E25F0}" type="slidenum">
               <a:rPr lang="en-US" smtClean="0"/>
               <a:t>‹#›</a:t>
             </a:fld>
@@ -1469,7 +1469,7 @@
     </p:spTree>
     <p:extLst>
       <p:ext uri="{BB962C8B-B14F-4D97-AF65-F5344CB8AC3E}">
-        <p14:creationId xmlns:p14="http://schemas.microsoft.com/office/powerpoint/2010/main" val="535842431"/>
+        <p14:creationId xmlns:p14="http://schemas.microsoft.com/office/powerpoint/2010/main" val="2861494746"/>
       </p:ext>
     </p:extLst>
   </p:cSld>
@@ -1501,7 +1501,7 @@
           <p:cNvPr id="2" name="Title 1">
             <a:extLst>
               <a:ext uri="{FF2B5EF4-FFF2-40B4-BE49-F238E27FC236}">
-                <a16:creationId xmlns:a16="http://schemas.microsoft.com/office/drawing/2014/main" id="{D4C5D0F8-BB08-538A-85F8-B6C707F5AEF7}"/>
+                <a16:creationId xmlns:a16="http://schemas.microsoft.com/office/drawing/2014/main" id="{4F649D64-88B4-9B2F-379B-2BF135781DE2}"/>
               </a:ext>
             </a:extLst>
           </p:cNvPr>
@@ -1534,7 +1534,7 @@
           <p:cNvPr id="3" name="Text Placeholder 2">
             <a:extLst>
               <a:ext uri="{FF2B5EF4-FFF2-40B4-BE49-F238E27FC236}">
-                <a16:creationId xmlns:a16="http://schemas.microsoft.com/office/drawing/2014/main" id="{A5BD7530-C00C-3B48-C1C6-B93B1A215E11}"/>
+                <a16:creationId xmlns:a16="http://schemas.microsoft.com/office/drawing/2014/main" id="{920B13B0-A1A7-1D81-D0B9-3AA7984359D7}"/>
               </a:ext>
             </a:extLst>
           </p:cNvPr>
@@ -1605,7 +1605,7 @@
           <p:cNvPr id="4" name="Content Placeholder 3">
             <a:extLst>
               <a:ext uri="{FF2B5EF4-FFF2-40B4-BE49-F238E27FC236}">
-                <a16:creationId xmlns:a16="http://schemas.microsoft.com/office/drawing/2014/main" id="{4768197D-5117-3F1D-C06B-19A0526E0D90}"/>
+                <a16:creationId xmlns:a16="http://schemas.microsoft.com/office/drawing/2014/main" id="{C431B78F-CEAE-E390-B72A-CC401A1E3764}"/>
               </a:ext>
             </a:extLst>
           </p:cNvPr>
@@ -1667,7 +1667,7 @@
           <p:cNvPr id="5" name="Text Placeholder 4">
             <a:extLst>
               <a:ext uri="{FF2B5EF4-FFF2-40B4-BE49-F238E27FC236}">
-                <a16:creationId xmlns:a16="http://schemas.microsoft.com/office/drawing/2014/main" id="{93FA39F5-ADE8-01D0-B578-5A3342B5008E}"/>
+                <a16:creationId xmlns:a16="http://schemas.microsoft.com/office/drawing/2014/main" id="{060A7819-9B54-EE46-B9D3-544A636E16C2}"/>
               </a:ext>
             </a:extLst>
           </p:cNvPr>
@@ -1738,7 +1738,7 @@
           <p:cNvPr id="6" name="Content Placeholder 5">
             <a:extLst>
               <a:ext uri="{FF2B5EF4-FFF2-40B4-BE49-F238E27FC236}">
-                <a16:creationId xmlns:a16="http://schemas.microsoft.com/office/drawing/2014/main" id="{5930FDFD-FD7D-0EF8-82C0-4CE3190E61C2}"/>
+                <a16:creationId xmlns:a16="http://schemas.microsoft.com/office/drawing/2014/main" id="{CD91F49E-CF74-BF5B-4DE0-B343E7C83F69}"/>
               </a:ext>
             </a:extLst>
           </p:cNvPr>
@@ -1800,7 +1800,7 @@
           <p:cNvPr id="7" name="Date Placeholder 6">
             <a:extLst>
               <a:ext uri="{FF2B5EF4-FFF2-40B4-BE49-F238E27FC236}">
-                <a16:creationId xmlns:a16="http://schemas.microsoft.com/office/drawing/2014/main" id="{F9A9EC34-8401-B86D-ABE3-96F0A522B6AC}"/>
+                <a16:creationId xmlns:a16="http://schemas.microsoft.com/office/drawing/2014/main" id="{9D8A6B85-9BE4-8BC4-232F-B6C736D4E8DD}"/>
               </a:ext>
             </a:extLst>
           </p:cNvPr>
@@ -1816,9 +1816,9 @@
           <a:bodyPr/>
           <a:lstStyle/>
           <a:p>
-            <a:fld id="{B1BDA628-8D64-4EDE-A986-760E78C72F76}" type="datetimeFigureOut">
+            <a:fld id="{722BF64C-CFE5-49BD-854E-797BD1FC74DB}" type="datetimeFigureOut">
               <a:rPr lang="en-US" smtClean="0"/>
-              <a:t>9/7/2026</a:t>
+              <a:t>9/8/2026</a:t>
             </a:fld>
             <a:endParaRPr lang="en-US"/>
           </a:p>
@@ -1829,7 +1829,7 @@
           <p:cNvPr id="8" name="Footer Placeholder 7">
             <a:extLst>
               <a:ext uri="{FF2B5EF4-FFF2-40B4-BE49-F238E27FC236}">
-                <a16:creationId xmlns:a16="http://schemas.microsoft.com/office/drawing/2014/main" id="{7CC81AC5-526C-2B32-7520-CC27823E81A2}"/>
+                <a16:creationId xmlns:a16="http://schemas.microsoft.com/office/drawing/2014/main" id="{876A35BC-E909-E140-09E2-4D5039709365}"/>
               </a:ext>
             </a:extLst>
           </p:cNvPr>
@@ -1854,7 +1854,7 @@
           <p:cNvPr id="9" name="Slide Number Placeholder 8">
             <a:extLst>
               <a:ext uri="{FF2B5EF4-FFF2-40B4-BE49-F238E27FC236}">
-                <a16:creationId xmlns:a16="http://schemas.microsoft.com/office/drawing/2014/main" id="{4FD63415-2252-6320-AAC8-6DBBA40681B5}"/>
+                <a16:creationId xmlns:a16="http://schemas.microsoft.com/office/drawing/2014/main" id="{2F016CB8-38EA-9C9C-145C-6D8DF93EBE28}"/>
               </a:ext>
             </a:extLst>
           </p:cNvPr>
@@ -1870,7 +1870,7 @@
           <a:bodyPr/>
           <a:lstStyle/>
           <a:p>
-            <a:fld id="{AE1BC162-5E59-493F-B0A3-6CDD71436CB9}" type="slidenum">
+            <a:fld id="{CBD6D984-39C0-49BD-A2E8-444D556E25F0}" type="slidenum">
               <a:rPr lang="en-US" smtClean="0"/>
               <a:t>‹#›</a:t>
             </a:fld>
@@ -1881,7 +1881,7 @@
     </p:spTree>
     <p:extLst>
       <p:ext uri="{BB962C8B-B14F-4D97-AF65-F5344CB8AC3E}">
-        <p14:creationId xmlns:p14="http://schemas.microsoft.com/office/powerpoint/2010/main" val="2356947717"/>
+        <p14:creationId xmlns:p14="http://schemas.microsoft.com/office/powerpoint/2010/main" val="1297915433"/>
       </p:ext>
     </p:extLst>
   </p:cSld>
@@ -1913,7 +1913,7 @@
           <p:cNvPr id="2" name="Title 1">
             <a:extLst>
               <a:ext uri="{FF2B5EF4-FFF2-40B4-BE49-F238E27FC236}">
-                <a16:creationId xmlns:a16="http://schemas.microsoft.com/office/drawing/2014/main" id="{95177F80-3C96-268F-3047-7D8FBD89A340}"/>
+                <a16:creationId xmlns:a16="http://schemas.microsoft.com/office/drawing/2014/main" id="{B1940CA6-69E5-ECE5-2884-CA29A5AF3841}"/>
               </a:ext>
             </a:extLst>
           </p:cNvPr>
@@ -1941,7 +1941,7 @@
           <p:cNvPr id="3" name="Date Placeholder 2">
             <a:extLst>
               <a:ext uri="{FF2B5EF4-FFF2-40B4-BE49-F238E27FC236}">
-                <a16:creationId xmlns:a16="http://schemas.microsoft.com/office/drawing/2014/main" id="{34118E44-7167-2A50-AEDC-DF73FF3742AC}"/>
+                <a16:creationId xmlns:a16="http://schemas.microsoft.com/office/drawing/2014/main" id="{19522D6E-4DED-345C-DE24-DDBE58316053}"/>
               </a:ext>
             </a:extLst>
           </p:cNvPr>
@@ -1957,9 +1957,9 @@
           <a:bodyPr/>
           <a:lstStyle/>
           <a:p>
-            <a:fld id="{B1BDA628-8D64-4EDE-A986-760E78C72F76}" type="datetimeFigureOut">
+            <a:fld id="{722BF64C-CFE5-49BD-854E-797BD1FC74DB}" type="datetimeFigureOut">
               <a:rPr lang="en-US" smtClean="0"/>
-              <a:t>9/7/2026</a:t>
+              <a:t>9/8/2026</a:t>
             </a:fld>
             <a:endParaRPr lang="en-US"/>
           </a:p>
@@ -1970,7 +1970,7 @@
           <p:cNvPr id="4" name="Footer Placeholder 3">
             <a:extLst>
               <a:ext uri="{FF2B5EF4-FFF2-40B4-BE49-F238E27FC236}">
-                <a16:creationId xmlns:a16="http://schemas.microsoft.com/office/drawing/2014/main" id="{171B24CB-07F0-8762-2D89-3338576B6A93}"/>
+                <a16:creationId xmlns:a16="http://schemas.microsoft.com/office/drawing/2014/main" id="{2BE336F5-0FE3-B2C4-2820-B589BC91168A}"/>
               </a:ext>
             </a:extLst>
           </p:cNvPr>
@@ -1995,7 +1995,7 @@
           <p:cNvPr id="5" name="Slide Number Placeholder 4">
             <a:extLst>
               <a:ext uri="{FF2B5EF4-FFF2-40B4-BE49-F238E27FC236}">
-                <a16:creationId xmlns:a16="http://schemas.microsoft.com/office/drawing/2014/main" id="{35E95366-33E1-AB51-60FC-724A0F1B739A}"/>
+                <a16:creationId xmlns:a16="http://schemas.microsoft.com/office/drawing/2014/main" id="{9345F903-BFC7-8354-1E11-B61316F900B5}"/>
               </a:ext>
             </a:extLst>
           </p:cNvPr>
@@ -2011,7 +2011,7 @@
           <a:bodyPr/>
           <a:lstStyle/>
           <a:p>
-            <a:fld id="{AE1BC162-5E59-493F-B0A3-6CDD71436CB9}" type="slidenum">
+            <a:fld id="{CBD6D984-39C0-49BD-A2E8-444D556E25F0}" type="slidenum">
               <a:rPr lang="en-US" smtClean="0"/>
               <a:t>‹#›</a:t>
             </a:fld>
@@ -2022,7 +2022,7 @@
     </p:spTree>
     <p:extLst>
       <p:ext uri="{BB962C8B-B14F-4D97-AF65-F5344CB8AC3E}">
-        <p14:creationId xmlns:p14="http://schemas.microsoft.com/office/powerpoint/2010/main" val="2360399526"/>
+        <p14:creationId xmlns:p14="http://schemas.microsoft.com/office/powerpoint/2010/main" val="1953971965"/>
       </p:ext>
     </p:extLst>
   </p:cSld>
@@ -2054,7 +2054,7 @@
           <p:cNvPr id="2" name="Date Placeholder 1">
             <a:extLst>
               <a:ext uri="{FF2B5EF4-FFF2-40B4-BE49-F238E27FC236}">
-                <a16:creationId xmlns:a16="http://schemas.microsoft.com/office/drawing/2014/main" id="{33E688D0-71AC-C069-84C3-0884415E8127}"/>
+                <a16:creationId xmlns:a16="http://schemas.microsoft.com/office/drawing/2014/main" id="{67F8969B-80AC-51F2-AB25-E7F2DC6C105B}"/>
               </a:ext>
             </a:extLst>
           </p:cNvPr>
@@ -2070,9 +2070,9 @@
           <a:bodyPr/>
           <a:lstStyle/>
           <a:p>
-            <a:fld id="{B1BDA628-8D64-4EDE-A986-760E78C72F76}" type="datetimeFigureOut">
+            <a:fld id="{722BF64C-CFE5-49BD-854E-797BD1FC74DB}" type="datetimeFigureOut">
               <a:rPr lang="en-US" smtClean="0"/>
-              <a:t>9/7/2026</a:t>
+              <a:t>9/8/2026</a:t>
             </a:fld>
             <a:endParaRPr lang="en-US"/>
           </a:p>
@@ -2083,7 +2083,7 @@
           <p:cNvPr id="3" name="Footer Placeholder 2">
             <a:extLst>
               <a:ext uri="{FF2B5EF4-FFF2-40B4-BE49-F238E27FC236}">
-                <a16:creationId xmlns:a16="http://schemas.microsoft.com/office/drawing/2014/main" id="{C1274E09-6F86-405F-C957-485183C5192A}"/>
+                <a16:creationId xmlns:a16="http://schemas.microsoft.com/office/drawing/2014/main" id="{6B61709B-55FF-6CD2-D33F-34D0BBADC166}"/>
               </a:ext>
             </a:extLst>
           </p:cNvPr>
@@ -2108,7 +2108,7 @@
           <p:cNvPr id="4" name="Slide Number Placeholder 3">
             <a:extLst>
               <a:ext uri="{FF2B5EF4-FFF2-40B4-BE49-F238E27FC236}">
-                <a16:creationId xmlns:a16="http://schemas.microsoft.com/office/drawing/2014/main" id="{7036B9F1-F388-A094-5BC1-9E9A32EA677F}"/>
+                <a16:creationId xmlns:a16="http://schemas.microsoft.com/office/drawing/2014/main" id="{53A1C30F-E853-B708-9DB9-0A074A53F7EF}"/>
               </a:ext>
             </a:extLst>
           </p:cNvPr>
@@ -2124,7 +2124,7 @@
           <a:bodyPr/>
           <a:lstStyle/>
           <a:p>
-            <a:fld id="{AE1BC162-5E59-493F-B0A3-6CDD71436CB9}" type="slidenum">
+            <a:fld id="{CBD6D984-39C0-49BD-A2E8-444D556E25F0}" type="slidenum">
               <a:rPr lang="en-US" smtClean="0"/>
               <a:t>‹#›</a:t>
             </a:fld>
@@ -2135,7 +2135,7 @@
     </p:spTree>
     <p:extLst>
       <p:ext uri="{BB962C8B-B14F-4D97-AF65-F5344CB8AC3E}">
-        <p14:creationId xmlns:p14="http://schemas.microsoft.com/office/powerpoint/2010/main" val="2092971686"/>
+        <p14:creationId xmlns:p14="http://schemas.microsoft.com/office/powerpoint/2010/main" val="2100098219"/>
       </p:ext>
     </p:extLst>
   </p:cSld>
@@ -2167,7 +2167,7 @@
           <p:cNvPr id="2" name="Title 1">
             <a:extLst>
               <a:ext uri="{FF2B5EF4-FFF2-40B4-BE49-F238E27FC236}">
-                <a16:creationId xmlns:a16="http://schemas.microsoft.com/office/drawing/2014/main" id="{9C53B5CA-3283-279C-08CE-5B4549BDED2B}"/>
+                <a16:creationId xmlns:a16="http://schemas.microsoft.com/office/drawing/2014/main" id="{0030ECD4-B004-07D5-4B18-F6C4C77893B1}"/>
               </a:ext>
             </a:extLst>
           </p:cNvPr>
@@ -2204,7 +2204,7 @@
           <p:cNvPr id="3" name="Content Placeholder 2">
             <a:extLst>
               <a:ext uri="{FF2B5EF4-FFF2-40B4-BE49-F238E27FC236}">
-                <a16:creationId xmlns:a16="http://schemas.microsoft.com/office/drawing/2014/main" id="{B778D255-DEE2-223E-7878-EA473082B42A}"/>
+                <a16:creationId xmlns:a16="http://schemas.microsoft.com/office/drawing/2014/main" id="{EA3A4EF8-3528-EDE3-CD66-575E8BE4BF0C}"/>
               </a:ext>
             </a:extLst>
           </p:cNvPr>
@@ -2294,7 +2294,7 @@
           <p:cNvPr id="4" name="Text Placeholder 3">
             <a:extLst>
               <a:ext uri="{FF2B5EF4-FFF2-40B4-BE49-F238E27FC236}">
-                <a16:creationId xmlns:a16="http://schemas.microsoft.com/office/drawing/2014/main" id="{67560878-F4F0-DF59-B678-76AC0AE2A6E4}"/>
+                <a16:creationId xmlns:a16="http://schemas.microsoft.com/office/drawing/2014/main" id="{68A3D683-B34C-4B82-3E3E-535B209850AD}"/>
               </a:ext>
             </a:extLst>
           </p:cNvPr>
@@ -2365,7 +2365,7 @@
           <p:cNvPr id="5" name="Date Placeholder 4">
             <a:extLst>
               <a:ext uri="{FF2B5EF4-FFF2-40B4-BE49-F238E27FC236}">
-                <a16:creationId xmlns:a16="http://schemas.microsoft.com/office/drawing/2014/main" id="{3E45EDDC-1EE3-691E-6D8B-0706E3EA775A}"/>
+                <a16:creationId xmlns:a16="http://schemas.microsoft.com/office/drawing/2014/main" id="{BF8BE371-8401-FD26-CCB1-CF092208819A}"/>
               </a:ext>
             </a:extLst>
           </p:cNvPr>
@@ -2381,9 +2381,9 @@
           <a:bodyPr/>
           <a:lstStyle/>
           <a:p>
-            <a:fld id="{B1BDA628-8D64-4EDE-A986-760E78C72F76}" type="datetimeFigureOut">
+            <a:fld id="{722BF64C-CFE5-49BD-854E-797BD1FC74DB}" type="datetimeFigureOut">
               <a:rPr lang="en-US" smtClean="0"/>
-              <a:t>9/7/2026</a:t>
+              <a:t>9/8/2026</a:t>
             </a:fld>
             <a:endParaRPr lang="en-US"/>
           </a:p>
@@ -2394,7 +2394,7 @@
           <p:cNvPr id="6" name="Footer Placeholder 5">
             <a:extLst>
               <a:ext uri="{FF2B5EF4-FFF2-40B4-BE49-F238E27FC236}">
-                <a16:creationId xmlns:a16="http://schemas.microsoft.com/office/drawing/2014/main" id="{84720E7E-28DD-E811-7DE1-DC199A46BAA8}"/>
+                <a16:creationId xmlns:a16="http://schemas.microsoft.com/office/drawing/2014/main" id="{F4E91FF7-D29C-672F-55DD-EF294762FDBF}"/>
               </a:ext>
             </a:extLst>
           </p:cNvPr>
@@ -2419,7 +2419,7 @@
           <p:cNvPr id="7" name="Slide Number Placeholder 6">
             <a:extLst>
               <a:ext uri="{FF2B5EF4-FFF2-40B4-BE49-F238E27FC236}">
-                <a16:creationId xmlns:a16="http://schemas.microsoft.com/office/drawing/2014/main" id="{B134CE45-A159-88B5-BAB9-B4A31590428D}"/>
+                <a16:creationId xmlns:a16="http://schemas.microsoft.com/office/drawing/2014/main" id="{28E9F89C-7DB6-D31E-0D40-4D8636FF54DA}"/>
               </a:ext>
             </a:extLst>
           </p:cNvPr>
@@ -2435,7 +2435,7 @@
           <a:bodyPr/>
           <a:lstStyle/>
           <a:p>
-            <a:fld id="{AE1BC162-5E59-493F-B0A3-6CDD71436CB9}" type="slidenum">
+            <a:fld id="{CBD6D984-39C0-49BD-A2E8-444D556E25F0}" type="slidenum">
               <a:rPr lang="en-US" smtClean="0"/>
               <a:t>‹#›</a:t>
             </a:fld>
@@ -2446,7 +2446,7 @@
     </p:spTree>
     <p:extLst>
       <p:ext uri="{BB962C8B-B14F-4D97-AF65-F5344CB8AC3E}">
-        <p14:creationId xmlns:p14="http://schemas.microsoft.com/office/powerpoint/2010/main" val="2820563139"/>
+        <p14:creationId xmlns:p14="http://schemas.microsoft.com/office/powerpoint/2010/main" val="2439654655"/>
       </p:ext>
     </p:extLst>
   </p:cSld>
@@ -2478,7 +2478,7 @@
           <p:cNvPr id="2" name="Title 1">
             <a:extLst>
               <a:ext uri="{FF2B5EF4-FFF2-40B4-BE49-F238E27FC236}">
-                <a16:creationId xmlns:a16="http://schemas.microsoft.com/office/drawing/2014/main" id="{30019C43-A78C-2E17-3273-7A65FCD9263B}"/>
+                <a16:creationId xmlns:a16="http://schemas.microsoft.com/office/drawing/2014/main" id="{82E35D35-35B5-B696-950C-EB67AF5C75D7}"/>
               </a:ext>
             </a:extLst>
           </p:cNvPr>
@@ -2515,7 +2515,7 @@
           <p:cNvPr id="3" name="Picture Placeholder 2">
             <a:extLst>
               <a:ext uri="{FF2B5EF4-FFF2-40B4-BE49-F238E27FC236}">
-                <a16:creationId xmlns:a16="http://schemas.microsoft.com/office/drawing/2014/main" id="{28C782F6-7145-A427-2C0A-FD00AC21CA37}"/>
+                <a16:creationId xmlns:a16="http://schemas.microsoft.com/office/drawing/2014/main" id="{9E64128F-4F57-BF7A-3BB0-3CF740239E8E}"/>
               </a:ext>
             </a:extLst>
           </p:cNvPr>
@@ -2582,7 +2582,7 @@
           <p:cNvPr id="4" name="Text Placeholder 3">
             <a:extLst>
               <a:ext uri="{FF2B5EF4-FFF2-40B4-BE49-F238E27FC236}">
-                <a16:creationId xmlns:a16="http://schemas.microsoft.com/office/drawing/2014/main" id="{096253F1-F5E2-7737-A47C-C8D156D9DCD5}"/>
+                <a16:creationId xmlns:a16="http://schemas.microsoft.com/office/drawing/2014/main" id="{342175C3-EA75-C656-42CA-B0F592DF1087}"/>
               </a:ext>
             </a:extLst>
           </p:cNvPr>
@@ -2653,7 +2653,7 @@
           <p:cNvPr id="5" name="Date Placeholder 4">
             <a:extLst>
               <a:ext uri="{FF2B5EF4-FFF2-40B4-BE49-F238E27FC236}">
-                <a16:creationId xmlns:a16="http://schemas.microsoft.com/office/drawing/2014/main" id="{F28D8BC8-101D-FC22-9889-894EC8833045}"/>
+                <a16:creationId xmlns:a16="http://schemas.microsoft.com/office/drawing/2014/main" id="{BED5BE65-2A00-72A9-4DA6-A4034CC1D0BF}"/>
               </a:ext>
             </a:extLst>
           </p:cNvPr>
@@ -2669,9 +2669,9 @@
           <a:bodyPr/>
           <a:lstStyle/>
           <a:p>
-            <a:fld id="{B1BDA628-8D64-4EDE-A986-760E78C72F76}" type="datetimeFigureOut">
+            <a:fld id="{722BF64C-CFE5-49BD-854E-797BD1FC74DB}" type="datetimeFigureOut">
               <a:rPr lang="en-US" smtClean="0"/>
-              <a:t>9/7/2026</a:t>
+              <a:t>9/8/2026</a:t>
             </a:fld>
             <a:endParaRPr lang="en-US"/>
           </a:p>
@@ -2682,7 +2682,7 @@
           <p:cNvPr id="6" name="Footer Placeholder 5">
             <a:extLst>
               <a:ext uri="{FF2B5EF4-FFF2-40B4-BE49-F238E27FC236}">
-                <a16:creationId xmlns:a16="http://schemas.microsoft.com/office/drawing/2014/main" id="{E917D2D8-60F3-75EB-C1E4-0396A9E7AC1B}"/>
+                <a16:creationId xmlns:a16="http://schemas.microsoft.com/office/drawing/2014/main" id="{78208A79-0B43-5670-5571-06BBD9D57C58}"/>
               </a:ext>
             </a:extLst>
           </p:cNvPr>
@@ -2707,7 +2707,7 @@
           <p:cNvPr id="7" name="Slide Number Placeholder 6">
             <a:extLst>
               <a:ext uri="{FF2B5EF4-FFF2-40B4-BE49-F238E27FC236}">
-                <a16:creationId xmlns:a16="http://schemas.microsoft.com/office/drawing/2014/main" id="{51A2372A-8D9A-3937-8DAF-3EBDEF44D082}"/>
+                <a16:creationId xmlns:a16="http://schemas.microsoft.com/office/drawing/2014/main" id="{5109CDA6-CCCF-A423-16D4-B1772746BA60}"/>
               </a:ext>
             </a:extLst>
           </p:cNvPr>
@@ -2723,7 +2723,7 @@
           <a:bodyPr/>
           <a:lstStyle/>
           <a:p>
-            <a:fld id="{AE1BC162-5E59-493F-B0A3-6CDD71436CB9}" type="slidenum">
+            <a:fld id="{CBD6D984-39C0-49BD-A2E8-444D556E25F0}" type="slidenum">
               <a:rPr lang="en-US" smtClean="0"/>
               <a:t>‹#›</a:t>
             </a:fld>
@@ -2734,7 +2734,7 @@
     </p:spTree>
     <p:extLst>
       <p:ext uri="{BB962C8B-B14F-4D97-AF65-F5344CB8AC3E}">
-        <p14:creationId xmlns:p14="http://schemas.microsoft.com/office/powerpoint/2010/main" val="161760901"/>
+        <p14:creationId xmlns:p14="http://schemas.microsoft.com/office/powerpoint/2010/main" val="660174568"/>
       </p:ext>
     </p:extLst>
   </p:cSld>
@@ -2771,7 +2771,7 @@
           <p:cNvPr id="2" name="Title Placeholder 1">
             <a:extLst>
               <a:ext uri="{FF2B5EF4-FFF2-40B4-BE49-F238E27FC236}">
-                <a16:creationId xmlns:a16="http://schemas.microsoft.com/office/drawing/2014/main" id="{24ED9E3D-14A0-8504-4819-1371521D6A9A}"/>
+                <a16:creationId xmlns:a16="http://schemas.microsoft.com/office/drawing/2014/main" id="{801AB2C0-A448-3435-4521-EA06149D7B0D}"/>
               </a:ext>
             </a:extLst>
           </p:cNvPr>
@@ -2809,7 +2809,7 @@
           <p:cNvPr id="3" name="Text Placeholder 2">
             <a:extLst>
               <a:ext uri="{FF2B5EF4-FFF2-40B4-BE49-F238E27FC236}">
-                <a16:creationId xmlns:a16="http://schemas.microsoft.com/office/drawing/2014/main" id="{707E85FB-D470-2B2E-0438-4B1D1B0C08AE}"/>
+                <a16:creationId xmlns:a16="http://schemas.microsoft.com/office/drawing/2014/main" id="{71C8A409-DAA0-8704-8BE0-8E51B8827606}"/>
               </a:ext>
             </a:extLst>
           </p:cNvPr>
@@ -2876,7 +2876,7 @@
           <p:cNvPr id="4" name="Date Placeholder 3">
             <a:extLst>
               <a:ext uri="{FF2B5EF4-FFF2-40B4-BE49-F238E27FC236}">
-                <a16:creationId xmlns:a16="http://schemas.microsoft.com/office/drawing/2014/main" id="{A0F13DD4-1872-BFA4-F183-B3EA26B8BDB1}"/>
+                <a16:creationId xmlns:a16="http://schemas.microsoft.com/office/drawing/2014/main" id="{174019E6-B83C-63BA-82CD-F1CF2C3B03DD}"/>
               </a:ext>
             </a:extLst>
           </p:cNvPr>
@@ -2910,9 +2910,9 @@
             </a:lvl1pPr>
           </a:lstStyle>
           <a:p>
-            <a:fld id="{B1BDA628-8D64-4EDE-A986-760E78C72F76}" type="datetimeFigureOut">
+            <a:fld id="{722BF64C-CFE5-49BD-854E-797BD1FC74DB}" type="datetimeFigureOut">
               <a:rPr lang="en-US" smtClean="0"/>
-              <a:t>9/7/2026</a:t>
+              <a:t>9/8/2026</a:t>
             </a:fld>
             <a:endParaRPr lang="en-US"/>
           </a:p>
@@ -2923,7 +2923,7 @@
           <p:cNvPr id="5" name="Footer Placeholder 4">
             <a:extLst>
               <a:ext uri="{FF2B5EF4-FFF2-40B4-BE49-F238E27FC236}">
-                <a16:creationId xmlns:a16="http://schemas.microsoft.com/office/drawing/2014/main" id="{61CECE2D-456D-2800-BA73-E42D588B19BA}"/>
+                <a16:creationId xmlns:a16="http://schemas.microsoft.com/office/drawing/2014/main" id="{EC046CFC-07E0-8313-9A24-F0E493E7D2B2}"/>
               </a:ext>
             </a:extLst>
           </p:cNvPr>
@@ -2966,7 +2966,7 @@
           <p:cNvPr id="6" name="Slide Number Placeholder 5">
             <a:extLst>
               <a:ext uri="{FF2B5EF4-FFF2-40B4-BE49-F238E27FC236}">
-                <a16:creationId xmlns:a16="http://schemas.microsoft.com/office/drawing/2014/main" id="{D8C0FDB5-E7DE-8AC1-C54F-E333E30C0379}"/>
+                <a16:creationId xmlns:a16="http://schemas.microsoft.com/office/drawing/2014/main" id="{D94AF097-8435-8E3D-B58D-1721EFEFFD53}"/>
               </a:ext>
             </a:extLst>
           </p:cNvPr>
@@ -3000,7 +3000,7 @@
             </a:lvl1pPr>
           </a:lstStyle>
           <a:p>
-            <a:fld id="{AE1BC162-5E59-493F-B0A3-6CDD71436CB9}" type="slidenum">
+            <a:fld id="{CBD6D984-39C0-49BD-A2E8-444D556E25F0}" type="slidenum">
               <a:rPr lang="en-US" smtClean="0"/>
               <a:t>‹#›</a:t>
             </a:fld>
@@ -3011,7 +3011,7 @@
     </p:spTree>
     <p:extLst>
       <p:ext uri="{BB962C8B-B14F-4D97-AF65-F5344CB8AC3E}">
-        <p14:creationId xmlns:p14="http://schemas.microsoft.com/office/powerpoint/2010/main" val="3664180107"/>
+        <p14:creationId xmlns:p14="http://schemas.microsoft.com/office/powerpoint/2010/main" val="2870661069"/>
       </p:ext>
     </p:extLst>
   </p:cSld>
@@ -3334,7 +3334,7 @@
           <p:cNvPr id="2" name="Rectangle 1">
             <a:extLst>
               <a:ext uri="{FF2B5EF4-FFF2-40B4-BE49-F238E27FC236}">
-                <a16:creationId xmlns:a16="http://schemas.microsoft.com/office/drawing/2014/main" id="{1A5AAAFA-E2FF-B196-E22C-E7A2E6D0D33F}"/>
+                <a16:creationId xmlns:a16="http://schemas.microsoft.com/office/drawing/2014/main" id="{C11D5ADB-EF5B-0DD8-827B-A820A20D4448}"/>
               </a:ext>
             </a:extLst>
           </p:cNvPr>
@@ -3402,7 +3402,7 @@
           <p:cNvPr id="3" name="Rectangle 2">
             <a:extLst>
               <a:ext uri="{FF2B5EF4-FFF2-40B4-BE49-F238E27FC236}">
-                <a16:creationId xmlns:a16="http://schemas.microsoft.com/office/drawing/2014/main" id="{FFD972C0-0E92-FDA9-10BC-7E82ABF34C88}"/>
+                <a16:creationId xmlns:a16="http://schemas.microsoft.com/office/drawing/2014/main" id="{FFEA9B9B-68F3-B7AF-9CF3-3538E36CDB09}"/>
               </a:ext>
             </a:extLst>
           </p:cNvPr>
@@ -3470,7 +3470,7 @@
           <p:cNvPr id="4" name="TextBox 3">
             <a:extLst>
               <a:ext uri="{FF2B5EF4-FFF2-40B4-BE49-F238E27FC236}">
-                <a16:creationId xmlns:a16="http://schemas.microsoft.com/office/drawing/2014/main" id="{AE3D6501-91D8-D42C-20DD-203DE7C8815E}"/>
+                <a16:creationId xmlns:a16="http://schemas.microsoft.com/office/drawing/2014/main" id="{A4DBE050-136F-7DE4-6610-4583D2E68FBF}"/>
               </a:ext>
             </a:extLst>
           </p:cNvPr>
@@ -3510,7 +3510,7 @@
           <p:cNvPr id="5" name="TextBox 4">
             <a:extLst>
               <a:ext uri="{FF2B5EF4-FFF2-40B4-BE49-F238E27FC236}">
-                <a16:creationId xmlns:a16="http://schemas.microsoft.com/office/drawing/2014/main" id="{3F018E29-8E7D-EAAA-97ED-8FE2106C3942}"/>
+                <a16:creationId xmlns:a16="http://schemas.microsoft.com/office/drawing/2014/main" id="{FC2A5E44-45F7-ED44-60E5-CFE270E1C3F9}"/>
               </a:ext>
             </a:extLst>
           </p:cNvPr>
@@ -3561,7 +3561,7 @@
           <p:cNvPr id="6" name="TextBox 5">
             <a:extLst>
               <a:ext uri="{FF2B5EF4-FFF2-40B4-BE49-F238E27FC236}">
-                <a16:creationId xmlns:a16="http://schemas.microsoft.com/office/drawing/2014/main" id="{D7B9B0EA-3FA4-91BA-E69B-05DC682F4E06}"/>
+                <a16:creationId xmlns:a16="http://schemas.microsoft.com/office/drawing/2014/main" id="{7737EFDF-8AAC-12C7-9378-96834EF09FEF}"/>
               </a:ext>
             </a:extLst>
           </p:cNvPr>
@@ -3632,7 +3632,7 @@
     </p:spTree>
     <p:extLst>
       <p:ext uri="{BB962C8B-B14F-4D97-AF65-F5344CB8AC3E}">
-        <p14:creationId xmlns:p14="http://schemas.microsoft.com/office/powerpoint/2010/main" val="1602243688"/>
+        <p14:creationId xmlns:p14="http://schemas.microsoft.com/office/powerpoint/2010/main" val="4240408428"/>
       </p:ext>
     </p:extLst>
   </p:cSld>
@@ -3664,7 +3664,7 @@
           <p:cNvPr id="2" name="Rectangle 1">
             <a:extLst>
               <a:ext uri="{FF2B5EF4-FFF2-40B4-BE49-F238E27FC236}">
-                <a16:creationId xmlns:a16="http://schemas.microsoft.com/office/drawing/2014/main" id="{9E973771-0CD2-FC1F-EF1C-8DCA993A5305}"/>
+                <a16:creationId xmlns:a16="http://schemas.microsoft.com/office/drawing/2014/main" id="{624F409A-FE02-D976-D985-51A68A762F34}"/>
               </a:ext>
             </a:extLst>
           </p:cNvPr>
@@ -3732,7 +3732,7 @@
           <p:cNvPr id="3" name="TextBox 2">
             <a:extLst>
               <a:ext uri="{FF2B5EF4-FFF2-40B4-BE49-F238E27FC236}">
-                <a16:creationId xmlns:a16="http://schemas.microsoft.com/office/drawing/2014/main" id="{584C9E00-38D6-0460-66B0-14B556EF5F76}"/>
+                <a16:creationId xmlns:a16="http://schemas.microsoft.com/office/drawing/2014/main" id="{CDD3904F-918D-51BB-D140-B340F09887DC}"/>
               </a:ext>
             </a:extLst>
           </p:cNvPr>
@@ -3772,7 +3772,7 @@
           <p:cNvPr id="4" name="TextBox 3">
             <a:extLst>
               <a:ext uri="{FF2B5EF4-FFF2-40B4-BE49-F238E27FC236}">
-                <a16:creationId xmlns:a16="http://schemas.microsoft.com/office/drawing/2014/main" id="{61A87F8B-5854-C885-EB22-BDECBF3FA489}"/>
+                <a16:creationId xmlns:a16="http://schemas.microsoft.com/office/drawing/2014/main" id="{73E5AB81-5461-CC5F-CC14-D1F0EDDCDEB4}"/>
               </a:ext>
             </a:extLst>
           </p:cNvPr>
@@ -3812,7 +3812,7 @@
           <p:cNvPr id="5" name="Rectangle 4">
             <a:extLst>
               <a:ext uri="{FF2B5EF4-FFF2-40B4-BE49-F238E27FC236}">
-                <a16:creationId xmlns:a16="http://schemas.microsoft.com/office/drawing/2014/main" id="{01B0F38B-9EA9-5569-6C45-9BE1A142E5BB}"/>
+                <a16:creationId xmlns:a16="http://schemas.microsoft.com/office/drawing/2014/main" id="{0F6AF385-647A-90D5-C089-C63279156C69}"/>
               </a:ext>
             </a:extLst>
           </p:cNvPr>
@@ -3866,7 +3866,7 @@
           <p:cNvPr id="6" name="TextBox 5">
             <a:extLst>
               <a:ext uri="{FF2B5EF4-FFF2-40B4-BE49-F238E27FC236}">
-                <a16:creationId xmlns:a16="http://schemas.microsoft.com/office/drawing/2014/main" id="{DB410AF2-B614-EFE3-5F5F-28297675438A}"/>
+                <a16:creationId xmlns:a16="http://schemas.microsoft.com/office/drawing/2014/main" id="{67C9E3E7-6C15-7812-0DD0-96B0A12EDF58}"/>
               </a:ext>
             </a:extLst>
           </p:cNvPr>
@@ -3876,7 +3876,7 @@
         <p:spPr>
           <a:xfrm>
             <a:off x="762000" y="1524000"/>
-            <a:ext cx="2286000" cy="2308324"/>
+            <a:ext cx="2286000" cy="2677656"/>
           </a:xfrm>
           <a:prstGeom prst="rect">
             <a:avLst/>
@@ -3896,7 +3896,7 @@
                 </a:solidFill>
                 <a:latin typeface="Arial" panose="020B0604020202020204" pitchFamily="34" charset="0"/>
               </a:rPr>
-              <a:t>COMPANY PROFILE</a:t>
+              <a:t>OFFICIAL PROFILE</a:t>
             </a:r>
           </a:p>
           <a:p>
@@ -3915,7 +3915,7 @@
                 </a:solidFill>
                 <a:latin typeface="Arial" panose="020B0604020202020204" pitchFamily="34" charset="0"/>
               </a:rPr>
-              <a:t>* Systems Engineering &amp; Enterprise Software</a:t>
+              <a:t>* Systems Engineering &amp; Custom Architecture.</a:t>
             </a:r>
           </a:p>
           <a:p>
@@ -3934,7 +3934,7 @@
                 </a:solidFill>
                 <a:latin typeface="Arial" panose="020B0604020202020204" pitchFamily="34" charset="0"/>
               </a:rPr>
-              <a:t>* Specializes in multi-branch retail, salon chains, and ERP workflows.</a:t>
+              <a:t>* Custom Biometric HRMS &amp; Payroll for Lay Bare branches.</a:t>
             </a:r>
           </a:p>
           <a:p>
@@ -3953,7 +3953,18 @@
                 </a:solidFill>
                 <a:latin typeface="Arial" panose="020B0604020202020204" pitchFamily="34" charset="0"/>
               </a:rPr>
-              <a:t>* Proven Partner: Lay Bare Salon network &amp; corporate retail.</a:t>
+              <a:t>* Official Company Profile:</a:t>
+            </a:r>
+          </a:p>
+          <a:p>
+            <a:r>
+              <a:rPr lang="en-US" sz="1200">
+                <a:solidFill>
+                  <a:srgbClr val="1E293B"/>
+                </a:solidFill>
+                <a:latin typeface="Arial" panose="020B0604020202020204" pitchFamily="34" charset="0"/>
+              </a:rPr>
+              <a:t>  https://drive.google.com/file/d/12qG_EbC35yH9k9Bl0uDCGp7shh1mfQ0B/view?usp=sharing</a:t>
             </a:r>
           </a:p>
         </p:txBody>
@@ -3963,7 +3974,7 @@
           <p:cNvPr id="7" name="Rectangle 6">
             <a:extLst>
               <a:ext uri="{FF2B5EF4-FFF2-40B4-BE49-F238E27FC236}">
-                <a16:creationId xmlns:a16="http://schemas.microsoft.com/office/drawing/2014/main" id="{08288E8A-E724-7FBD-E402-5B3E67508C49}"/>
+                <a16:creationId xmlns:a16="http://schemas.microsoft.com/office/drawing/2014/main" id="{A1BB7063-CA1E-341D-29EC-03D26B272017}"/>
               </a:ext>
             </a:extLst>
           </p:cNvPr>
@@ -4017,7 +4028,7 @@
           <p:cNvPr id="8" name="TextBox 7">
             <a:extLst>
               <a:ext uri="{FF2B5EF4-FFF2-40B4-BE49-F238E27FC236}">
-                <a16:creationId xmlns:a16="http://schemas.microsoft.com/office/drawing/2014/main" id="{3695F833-0182-188D-0A4E-9BF5D58F410F}"/>
+                <a16:creationId xmlns:a16="http://schemas.microsoft.com/office/drawing/2014/main" id="{A79E8623-8B74-14DC-A0AA-684FC5123395}"/>
               </a:ext>
             </a:extLst>
           </p:cNvPr>
@@ -4133,7 +4144,7 @@
           <p:cNvPr id="9" name="Rectangle 8">
             <a:extLst>
               <a:ext uri="{FF2B5EF4-FFF2-40B4-BE49-F238E27FC236}">
-                <a16:creationId xmlns:a16="http://schemas.microsoft.com/office/drawing/2014/main" id="{F1A01BAC-3A83-B757-DA39-4F9F632A4512}"/>
+                <a16:creationId xmlns:a16="http://schemas.microsoft.com/office/drawing/2014/main" id="{41919977-6C17-B23A-BF27-4C572A12E451}"/>
               </a:ext>
             </a:extLst>
           </p:cNvPr>
@@ -4187,7 +4198,7 @@
           <p:cNvPr id="10" name="TextBox 9">
             <a:extLst>
               <a:ext uri="{FF2B5EF4-FFF2-40B4-BE49-F238E27FC236}">
-                <a16:creationId xmlns:a16="http://schemas.microsoft.com/office/drawing/2014/main" id="{C6B083E8-9D8E-ACCC-2C42-68E2CB8CB3B3}"/>
+                <a16:creationId xmlns:a16="http://schemas.microsoft.com/office/drawing/2014/main" id="{C887D83B-3216-A679-B8D3-809293C19454}"/>
               </a:ext>
             </a:extLst>
           </p:cNvPr>
@@ -4301,7 +4312,7 @@
           <p:cNvPr id="11" name="Rectangle 10">
             <a:extLst>
               <a:ext uri="{FF2B5EF4-FFF2-40B4-BE49-F238E27FC236}">
-                <a16:creationId xmlns:a16="http://schemas.microsoft.com/office/drawing/2014/main" id="{A9480023-FD48-D076-6251-1D98B05B5243}"/>
+                <a16:creationId xmlns:a16="http://schemas.microsoft.com/office/drawing/2014/main" id="{DAEE1C53-A166-40B4-051F-5DFEACE7A04D}"/>
               </a:ext>
             </a:extLst>
           </p:cNvPr>
@@ -4355,7 +4366,7 @@
           <p:cNvPr id="12" name="TextBox 11">
             <a:extLst>
               <a:ext uri="{FF2B5EF4-FFF2-40B4-BE49-F238E27FC236}">
-                <a16:creationId xmlns:a16="http://schemas.microsoft.com/office/drawing/2014/main" id="{F2D80209-A62F-391A-C3DD-559DD20D67DE}"/>
+                <a16:creationId xmlns:a16="http://schemas.microsoft.com/office/drawing/2014/main" id="{DE41F221-9FA4-8B82-C170-1D3F4F513E5B}"/>
               </a:ext>
             </a:extLst>
           </p:cNvPr>
@@ -4469,7 +4480,7 @@
     </p:spTree>
     <p:extLst>
       <p:ext uri="{BB962C8B-B14F-4D97-AF65-F5344CB8AC3E}">
-        <p14:creationId xmlns:p14="http://schemas.microsoft.com/office/powerpoint/2010/main" val="553865155"/>
+        <p14:creationId xmlns:p14="http://schemas.microsoft.com/office/powerpoint/2010/main" val="1963300801"/>
       </p:ext>
     </p:extLst>
   </p:cSld>
@@ -4501,7 +4512,7 @@
           <p:cNvPr id="2" name="Rectangle 1">
             <a:extLst>
               <a:ext uri="{FF2B5EF4-FFF2-40B4-BE49-F238E27FC236}">
-                <a16:creationId xmlns:a16="http://schemas.microsoft.com/office/drawing/2014/main" id="{DD3963EC-9F32-F760-CD38-72116F9BB01C}"/>
+                <a16:creationId xmlns:a16="http://schemas.microsoft.com/office/drawing/2014/main" id="{46C62398-6EB9-DE10-9E84-BA8085BB13CB}"/>
               </a:ext>
             </a:extLst>
           </p:cNvPr>
@@ -4569,7 +4580,7 @@
           <p:cNvPr id="3" name="TextBox 2">
             <a:extLst>
               <a:ext uri="{FF2B5EF4-FFF2-40B4-BE49-F238E27FC236}">
-                <a16:creationId xmlns:a16="http://schemas.microsoft.com/office/drawing/2014/main" id="{E138986A-FC28-D7A0-23D6-3C0D4675FBD6}"/>
+                <a16:creationId xmlns:a16="http://schemas.microsoft.com/office/drawing/2014/main" id="{19F06373-65F5-40F5-FAC5-25519DC92627}"/>
               </a:ext>
             </a:extLst>
           </p:cNvPr>
@@ -4609,7 +4620,7 @@
           <p:cNvPr id="4" name="Rectangle 3">
             <a:extLst>
               <a:ext uri="{FF2B5EF4-FFF2-40B4-BE49-F238E27FC236}">
-                <a16:creationId xmlns:a16="http://schemas.microsoft.com/office/drawing/2014/main" id="{C0F81D3E-DB74-155A-2C1F-CDE65C2A3737}"/>
+                <a16:creationId xmlns:a16="http://schemas.microsoft.com/office/drawing/2014/main" id="{1837D741-6125-B455-61C6-D7DFE4106D56}"/>
               </a:ext>
             </a:extLst>
           </p:cNvPr>
@@ -4663,7 +4674,7 @@
           <p:cNvPr id="5" name="TextBox 4">
             <a:extLst>
               <a:ext uri="{FF2B5EF4-FFF2-40B4-BE49-F238E27FC236}">
-                <a16:creationId xmlns:a16="http://schemas.microsoft.com/office/drawing/2014/main" id="{393ADFF9-4F5F-09BD-5DEB-7E8052DCBEF0}"/>
+                <a16:creationId xmlns:a16="http://schemas.microsoft.com/office/drawing/2014/main" id="{88F96C22-6FE3-F457-D2F7-97FE714641BE}"/>
               </a:ext>
             </a:extLst>
           </p:cNvPr>
@@ -4760,7 +4771,7 @@
           <p:cNvPr id="6" name="Rectangle 5">
             <a:extLst>
               <a:ext uri="{FF2B5EF4-FFF2-40B4-BE49-F238E27FC236}">
-                <a16:creationId xmlns:a16="http://schemas.microsoft.com/office/drawing/2014/main" id="{8403D511-12E3-0E67-9317-331EB0886FA4}"/>
+                <a16:creationId xmlns:a16="http://schemas.microsoft.com/office/drawing/2014/main" id="{38A38FA6-D4AA-5D7A-F1EB-8302203CAD1A}"/>
               </a:ext>
             </a:extLst>
           </p:cNvPr>
@@ -4814,7 +4825,7 @@
           <p:cNvPr id="7" name="TextBox 6">
             <a:extLst>
               <a:ext uri="{FF2B5EF4-FFF2-40B4-BE49-F238E27FC236}">
-                <a16:creationId xmlns:a16="http://schemas.microsoft.com/office/drawing/2014/main" id="{1FE3B9FD-FADB-47CC-92AF-7D565506E610}"/>
+                <a16:creationId xmlns:a16="http://schemas.microsoft.com/office/drawing/2014/main" id="{EAF6B9D4-9956-18E5-1FBE-39B2737F3072}"/>
               </a:ext>
             </a:extLst>
           </p:cNvPr>
@@ -4936,7 +4947,7 @@
           <p:cNvPr id="8" name="Rectangle 7">
             <a:extLst>
               <a:ext uri="{FF2B5EF4-FFF2-40B4-BE49-F238E27FC236}">
-                <a16:creationId xmlns:a16="http://schemas.microsoft.com/office/drawing/2014/main" id="{934009B3-3187-7FF5-79A0-88D811347490}"/>
+                <a16:creationId xmlns:a16="http://schemas.microsoft.com/office/drawing/2014/main" id="{0FDA6496-556E-8FDF-977B-60DD79AC231D}"/>
               </a:ext>
             </a:extLst>
           </p:cNvPr>
@@ -4990,7 +5001,7 @@
           <p:cNvPr id="9" name="TextBox 8">
             <a:extLst>
               <a:ext uri="{FF2B5EF4-FFF2-40B4-BE49-F238E27FC236}">
-                <a16:creationId xmlns:a16="http://schemas.microsoft.com/office/drawing/2014/main" id="{A64E2DA1-C7DD-7B30-89F5-AB9949BAF2F8}"/>
+                <a16:creationId xmlns:a16="http://schemas.microsoft.com/office/drawing/2014/main" id="{920ACF0D-6686-6F15-F47A-9060659DA79A}"/>
               </a:ext>
             </a:extLst>
           </p:cNvPr>
@@ -5085,7 +5096,7 @@
     </p:spTree>
     <p:extLst>
       <p:ext uri="{BB962C8B-B14F-4D97-AF65-F5344CB8AC3E}">
-        <p14:creationId xmlns:p14="http://schemas.microsoft.com/office/powerpoint/2010/main" val="591161443"/>
+        <p14:creationId xmlns:p14="http://schemas.microsoft.com/office/powerpoint/2010/main" val="3235372710"/>
       </p:ext>
     </p:extLst>
   </p:cSld>
@@ -5117,7 +5128,7 @@
           <p:cNvPr id="2" name="Rectangle 1">
             <a:extLst>
               <a:ext uri="{FF2B5EF4-FFF2-40B4-BE49-F238E27FC236}">
-                <a16:creationId xmlns:a16="http://schemas.microsoft.com/office/drawing/2014/main" id="{BC31633D-691D-E984-DBFA-D2B05EAB3ACF}"/>
+                <a16:creationId xmlns:a16="http://schemas.microsoft.com/office/drawing/2014/main" id="{53C6A790-5E7C-AA67-E200-3B4B4BCB8349}"/>
               </a:ext>
             </a:extLst>
           </p:cNvPr>
@@ -5185,7 +5196,7 @@
           <p:cNvPr id="3" name="TextBox 2">
             <a:extLst>
               <a:ext uri="{FF2B5EF4-FFF2-40B4-BE49-F238E27FC236}">
-                <a16:creationId xmlns:a16="http://schemas.microsoft.com/office/drawing/2014/main" id="{6CDC5056-481D-D68B-A8CE-E4F2F00769E5}"/>
+                <a16:creationId xmlns:a16="http://schemas.microsoft.com/office/drawing/2014/main" id="{DC21E4F2-E7C6-81CD-C98C-2478A986358B}"/>
               </a:ext>
             </a:extLst>
           </p:cNvPr>
@@ -5225,7 +5236,7 @@
           <p:cNvPr id="4" name="TextBox 3">
             <a:extLst>
               <a:ext uri="{FF2B5EF4-FFF2-40B4-BE49-F238E27FC236}">
-                <a16:creationId xmlns:a16="http://schemas.microsoft.com/office/drawing/2014/main" id="{41CBAC71-F196-1D7B-3379-4ED1D40D214E}"/>
+                <a16:creationId xmlns:a16="http://schemas.microsoft.com/office/drawing/2014/main" id="{CE0E275B-71CD-4218-AE06-2C72215A802C}"/>
               </a:ext>
             </a:extLst>
           </p:cNvPr>
@@ -5265,7 +5276,7 @@
           <p:cNvPr id="5" name="Rectangle 4">
             <a:extLst>
               <a:ext uri="{FF2B5EF4-FFF2-40B4-BE49-F238E27FC236}">
-                <a16:creationId xmlns:a16="http://schemas.microsoft.com/office/drawing/2014/main" id="{CA446CEA-ECF8-FAF5-617B-937152F1FB2C}"/>
+                <a16:creationId xmlns:a16="http://schemas.microsoft.com/office/drawing/2014/main" id="{1F93FECE-F769-1646-B634-C101A742482C}"/>
               </a:ext>
             </a:extLst>
           </p:cNvPr>
@@ -5333,7 +5344,7 @@
           <p:cNvPr id="6" name="TextBox 5">
             <a:extLst>
               <a:ext uri="{FF2B5EF4-FFF2-40B4-BE49-F238E27FC236}">
-                <a16:creationId xmlns:a16="http://schemas.microsoft.com/office/drawing/2014/main" id="{22B802BC-CD8D-E969-C3E2-7C1AB97B00EF}"/>
+                <a16:creationId xmlns:a16="http://schemas.microsoft.com/office/drawing/2014/main" id="{FCBB915C-6534-099B-C835-2FBFFF351B08}"/>
               </a:ext>
             </a:extLst>
           </p:cNvPr>
@@ -5411,7 +5422,7 @@
           <p:cNvPr id="7" name="Rectangle 6">
             <a:extLst>
               <a:ext uri="{FF2B5EF4-FFF2-40B4-BE49-F238E27FC236}">
-                <a16:creationId xmlns:a16="http://schemas.microsoft.com/office/drawing/2014/main" id="{45375BF6-2E6D-D677-3704-F6B81ACE12C9}"/>
+                <a16:creationId xmlns:a16="http://schemas.microsoft.com/office/drawing/2014/main" id="{0E0F4F80-30C4-A4A0-DDFE-53E397CED00C}"/>
               </a:ext>
             </a:extLst>
           </p:cNvPr>
@@ -5479,7 +5490,7 @@
           <p:cNvPr id="8" name="TextBox 7">
             <a:extLst>
               <a:ext uri="{FF2B5EF4-FFF2-40B4-BE49-F238E27FC236}">
-                <a16:creationId xmlns:a16="http://schemas.microsoft.com/office/drawing/2014/main" id="{6D62BC8B-C111-DBCD-025D-7A922AC84391}"/>
+                <a16:creationId xmlns:a16="http://schemas.microsoft.com/office/drawing/2014/main" id="{8A1EEE18-2025-C262-88CA-C42D2D3BF167}"/>
               </a:ext>
             </a:extLst>
           </p:cNvPr>
@@ -5557,7 +5568,7 @@
           <p:cNvPr id="9" name="Rectangle 8">
             <a:extLst>
               <a:ext uri="{FF2B5EF4-FFF2-40B4-BE49-F238E27FC236}">
-                <a16:creationId xmlns:a16="http://schemas.microsoft.com/office/drawing/2014/main" id="{CAA6BA57-5FEC-3321-E36A-765EDFE26004}"/>
+                <a16:creationId xmlns:a16="http://schemas.microsoft.com/office/drawing/2014/main" id="{4B688843-1097-6074-DD7E-40335F36D5FC}"/>
               </a:ext>
             </a:extLst>
           </p:cNvPr>
@@ -5625,7 +5636,7 @@
           <p:cNvPr id="10" name="TextBox 9">
             <a:extLst>
               <a:ext uri="{FF2B5EF4-FFF2-40B4-BE49-F238E27FC236}">
-                <a16:creationId xmlns:a16="http://schemas.microsoft.com/office/drawing/2014/main" id="{43D6A171-0E50-EBA4-5ECD-DE070C44A8EE}"/>
+                <a16:creationId xmlns:a16="http://schemas.microsoft.com/office/drawing/2014/main" id="{7B1ED959-E07A-4A33-7D50-BBE294B59E1C}"/>
               </a:ext>
             </a:extLst>
           </p:cNvPr>
@@ -5703,7 +5714,7 @@
           <p:cNvPr id="11" name="Rectangle 10">
             <a:extLst>
               <a:ext uri="{FF2B5EF4-FFF2-40B4-BE49-F238E27FC236}">
-                <a16:creationId xmlns:a16="http://schemas.microsoft.com/office/drawing/2014/main" id="{A5B535C7-29EA-3CC5-91CE-51C1EFA4F3D8}"/>
+                <a16:creationId xmlns:a16="http://schemas.microsoft.com/office/drawing/2014/main" id="{730FCCE8-CF7F-3E25-559A-3C38747F6C14}"/>
               </a:ext>
             </a:extLst>
           </p:cNvPr>
@@ -5771,7 +5782,7 @@
           <p:cNvPr id="12" name="TextBox 11">
             <a:extLst>
               <a:ext uri="{FF2B5EF4-FFF2-40B4-BE49-F238E27FC236}">
-                <a16:creationId xmlns:a16="http://schemas.microsoft.com/office/drawing/2014/main" id="{F3F7C7E3-38BD-0F96-953A-22CB88A520B1}"/>
+                <a16:creationId xmlns:a16="http://schemas.microsoft.com/office/drawing/2014/main" id="{BEE4A262-37AA-AFD0-146B-0D2533F17F42}"/>
               </a:ext>
             </a:extLst>
           </p:cNvPr>
@@ -5847,7 +5858,7 @@
     </p:spTree>
     <p:extLst>
       <p:ext uri="{BB962C8B-B14F-4D97-AF65-F5344CB8AC3E}">
-        <p14:creationId xmlns:p14="http://schemas.microsoft.com/office/powerpoint/2010/main" val="3768586606"/>
+        <p14:creationId xmlns:p14="http://schemas.microsoft.com/office/powerpoint/2010/main" val="3719521690"/>
       </p:ext>
     </p:extLst>
   </p:cSld>
@@ -5879,7 +5890,7 @@
           <p:cNvPr id="2" name="Rectangle 1">
             <a:extLst>
               <a:ext uri="{FF2B5EF4-FFF2-40B4-BE49-F238E27FC236}">
-                <a16:creationId xmlns:a16="http://schemas.microsoft.com/office/drawing/2014/main" id="{B0C66725-79E2-8A3C-2D10-555981D51398}"/>
+                <a16:creationId xmlns:a16="http://schemas.microsoft.com/office/drawing/2014/main" id="{2265EF12-4C15-21A2-DD70-AC5E31F35BD8}"/>
               </a:ext>
             </a:extLst>
           </p:cNvPr>
@@ -5947,7 +5958,7 @@
           <p:cNvPr id="3" name="TextBox 2">
             <a:extLst>
               <a:ext uri="{FF2B5EF4-FFF2-40B4-BE49-F238E27FC236}">
-                <a16:creationId xmlns:a16="http://schemas.microsoft.com/office/drawing/2014/main" id="{063EF908-C6A3-2EC1-951C-68F0A250E98E}"/>
+                <a16:creationId xmlns:a16="http://schemas.microsoft.com/office/drawing/2014/main" id="{D290BE0C-FAFB-6FC5-0274-F3F15C07DEA7}"/>
               </a:ext>
             </a:extLst>
           </p:cNvPr>
@@ -5987,7 +5998,7 @@
           <p:cNvPr id="4" name="Rectangle 3">
             <a:extLst>
               <a:ext uri="{FF2B5EF4-FFF2-40B4-BE49-F238E27FC236}">
-                <a16:creationId xmlns:a16="http://schemas.microsoft.com/office/drawing/2014/main" id="{EBC0F6EF-E5CD-CD75-990F-0CAD02264877}"/>
+                <a16:creationId xmlns:a16="http://schemas.microsoft.com/office/drawing/2014/main" id="{B21DB469-0A2C-157C-39C8-38A2DC20EBCB}"/>
               </a:ext>
             </a:extLst>
           </p:cNvPr>
@@ -6041,7 +6052,7 @@
           <p:cNvPr id="5" name="TextBox 4">
             <a:extLst>
               <a:ext uri="{FF2B5EF4-FFF2-40B4-BE49-F238E27FC236}">
-                <a16:creationId xmlns:a16="http://schemas.microsoft.com/office/drawing/2014/main" id="{A0F3AB56-2B9B-DA44-3FFC-433120FD4BA5}"/>
+                <a16:creationId xmlns:a16="http://schemas.microsoft.com/office/drawing/2014/main" id="{DAA3F216-EA07-23D9-6E9E-1BFA446265B3}"/>
               </a:ext>
             </a:extLst>
           </p:cNvPr>
@@ -6212,7 +6223,7 @@
           <p:cNvPr id="6" name="Rectangle 5">
             <a:extLst>
               <a:ext uri="{FF2B5EF4-FFF2-40B4-BE49-F238E27FC236}">
-                <a16:creationId xmlns:a16="http://schemas.microsoft.com/office/drawing/2014/main" id="{0D3C683C-992D-B5E0-C3DA-8C0B41C516EF}"/>
+                <a16:creationId xmlns:a16="http://schemas.microsoft.com/office/drawing/2014/main" id="{7EB6BA46-5165-1B16-A26F-BE076C40944A}"/>
               </a:ext>
             </a:extLst>
           </p:cNvPr>
@@ -6266,7 +6277,7 @@
           <p:cNvPr id="7" name="TextBox 6">
             <a:extLst>
               <a:ext uri="{FF2B5EF4-FFF2-40B4-BE49-F238E27FC236}">
-                <a16:creationId xmlns:a16="http://schemas.microsoft.com/office/drawing/2014/main" id="{905F5731-3E0D-B63D-7C9F-52D2051B9813}"/>
+                <a16:creationId xmlns:a16="http://schemas.microsoft.com/office/drawing/2014/main" id="{87681180-BA1D-22BD-147C-290568EF45F7}"/>
               </a:ext>
             </a:extLst>
           </p:cNvPr>
@@ -6402,7 +6413,7 @@
     </p:spTree>
     <p:extLst>
       <p:ext uri="{BB962C8B-B14F-4D97-AF65-F5344CB8AC3E}">
-        <p14:creationId xmlns:p14="http://schemas.microsoft.com/office/powerpoint/2010/main" val="3104031517"/>
+        <p14:creationId xmlns:p14="http://schemas.microsoft.com/office/powerpoint/2010/main" val="2443353593"/>
       </p:ext>
     </p:extLst>
   </p:cSld>
@@ -6434,7 +6445,7 @@
           <p:cNvPr id="2" name="Rectangle 1">
             <a:extLst>
               <a:ext uri="{FF2B5EF4-FFF2-40B4-BE49-F238E27FC236}">
-                <a16:creationId xmlns:a16="http://schemas.microsoft.com/office/drawing/2014/main" id="{3EDFE6AE-CB4E-E921-6CBA-24446DB22120}"/>
+                <a16:creationId xmlns:a16="http://schemas.microsoft.com/office/drawing/2014/main" id="{31851BF6-0BA6-52EB-021F-78FB60A256DD}"/>
               </a:ext>
             </a:extLst>
           </p:cNvPr>
@@ -6502,7 +6513,7 @@
           <p:cNvPr id="3" name="TextBox 2">
             <a:extLst>
               <a:ext uri="{FF2B5EF4-FFF2-40B4-BE49-F238E27FC236}">
-                <a16:creationId xmlns:a16="http://schemas.microsoft.com/office/drawing/2014/main" id="{648A47AF-8D02-8926-DF50-4E1F18617757}"/>
+                <a16:creationId xmlns:a16="http://schemas.microsoft.com/office/drawing/2014/main" id="{7C42FF26-2BED-B342-F3D3-73915995AC40}"/>
               </a:ext>
             </a:extLst>
           </p:cNvPr>
@@ -6542,7 +6553,7 @@
           <p:cNvPr id="4" name="TextBox 3">
             <a:extLst>
               <a:ext uri="{FF2B5EF4-FFF2-40B4-BE49-F238E27FC236}">
-                <a16:creationId xmlns:a16="http://schemas.microsoft.com/office/drawing/2014/main" id="{8BEAE4C7-E454-A1E8-3F7E-5C447F61C0EE}"/>
+                <a16:creationId xmlns:a16="http://schemas.microsoft.com/office/drawing/2014/main" id="{DE1DB4C1-EE02-CE08-DC52-0768D2F12F60}"/>
               </a:ext>
             </a:extLst>
           </p:cNvPr>
@@ -6582,7 +6593,7 @@
           <p:cNvPr id="5" name="Rectangle 4">
             <a:extLst>
               <a:ext uri="{FF2B5EF4-FFF2-40B4-BE49-F238E27FC236}">
-                <a16:creationId xmlns:a16="http://schemas.microsoft.com/office/drawing/2014/main" id="{DCF9F6E6-045E-ADC2-BD60-5636A18B89CD}"/>
+                <a16:creationId xmlns:a16="http://schemas.microsoft.com/office/drawing/2014/main" id="{E20B23A7-6CC1-16E4-7260-9EA9124233F4}"/>
               </a:ext>
             </a:extLst>
           </p:cNvPr>
@@ -6650,7 +6661,7 @@
           <p:cNvPr id="6" name="TextBox 5">
             <a:extLst>
               <a:ext uri="{FF2B5EF4-FFF2-40B4-BE49-F238E27FC236}">
-                <a16:creationId xmlns:a16="http://schemas.microsoft.com/office/drawing/2014/main" id="{430B1B54-8B2C-FF66-FCBB-C2E43962ADF0}"/>
+                <a16:creationId xmlns:a16="http://schemas.microsoft.com/office/drawing/2014/main" id="{5DB80C1C-C311-B331-5558-DA4C4B6FACF3}"/>
               </a:ext>
             </a:extLst>
           </p:cNvPr>
@@ -6742,7 +6753,7 @@
           <p:cNvPr id="7" name="Rectangle 6">
             <a:extLst>
               <a:ext uri="{FF2B5EF4-FFF2-40B4-BE49-F238E27FC236}">
-                <a16:creationId xmlns:a16="http://schemas.microsoft.com/office/drawing/2014/main" id="{1A99AB97-7032-F619-621A-8A4C0FEAA16D}"/>
+                <a16:creationId xmlns:a16="http://schemas.microsoft.com/office/drawing/2014/main" id="{750FD015-049C-AC57-DB0A-F39A820579DC}"/>
               </a:ext>
             </a:extLst>
           </p:cNvPr>
@@ -6810,7 +6821,7 @@
           <p:cNvPr id="8" name="TextBox 7">
             <a:extLst>
               <a:ext uri="{FF2B5EF4-FFF2-40B4-BE49-F238E27FC236}">
-                <a16:creationId xmlns:a16="http://schemas.microsoft.com/office/drawing/2014/main" id="{8538EB22-710E-44E7-C935-DE12F653D963}"/>
+                <a16:creationId xmlns:a16="http://schemas.microsoft.com/office/drawing/2014/main" id="{E4865220-E87F-7843-C349-2706CBCD1CA5}"/>
               </a:ext>
             </a:extLst>
           </p:cNvPr>
@@ -6902,7 +6913,7 @@
           <p:cNvPr id="9" name="Rectangle 8">
             <a:extLst>
               <a:ext uri="{FF2B5EF4-FFF2-40B4-BE49-F238E27FC236}">
-                <a16:creationId xmlns:a16="http://schemas.microsoft.com/office/drawing/2014/main" id="{7A7B8EF8-E003-B28C-8AB9-EAF69E7FD898}"/>
+                <a16:creationId xmlns:a16="http://schemas.microsoft.com/office/drawing/2014/main" id="{488D5142-4071-C6E5-F636-E63C27D726FB}"/>
               </a:ext>
             </a:extLst>
           </p:cNvPr>
@@ -6970,7 +6981,7 @@
           <p:cNvPr id="10" name="TextBox 9">
             <a:extLst>
               <a:ext uri="{FF2B5EF4-FFF2-40B4-BE49-F238E27FC236}">
-                <a16:creationId xmlns:a16="http://schemas.microsoft.com/office/drawing/2014/main" id="{F64E074C-37A5-F9B9-3CFD-4BB54D6078CE}"/>
+                <a16:creationId xmlns:a16="http://schemas.microsoft.com/office/drawing/2014/main" id="{2D07651B-53D4-0520-5C26-908322959597}"/>
               </a:ext>
             </a:extLst>
           </p:cNvPr>
@@ -7051,7 +7062,7 @@
           <p:cNvPr id="11" name="Rectangle 10">
             <a:extLst>
               <a:ext uri="{FF2B5EF4-FFF2-40B4-BE49-F238E27FC236}">
-                <a16:creationId xmlns:a16="http://schemas.microsoft.com/office/drawing/2014/main" id="{A071AABB-C4D9-9C00-5BD5-989A4EDB0C24}"/>
+                <a16:creationId xmlns:a16="http://schemas.microsoft.com/office/drawing/2014/main" id="{DFEA3DF0-3B40-9A17-91ED-61C226409370}"/>
               </a:ext>
             </a:extLst>
           </p:cNvPr>
@@ -7119,7 +7130,7 @@
           <p:cNvPr id="12" name="TextBox 11">
             <a:extLst>
               <a:ext uri="{FF2B5EF4-FFF2-40B4-BE49-F238E27FC236}">
-                <a16:creationId xmlns:a16="http://schemas.microsoft.com/office/drawing/2014/main" id="{E365AFBF-8F0D-E3CC-E9A0-D4209CAAF107}"/>
+                <a16:creationId xmlns:a16="http://schemas.microsoft.com/office/drawing/2014/main" id="{110BAF07-FA73-ECF0-8439-25756F16C0B0}"/>
               </a:ext>
             </a:extLst>
           </p:cNvPr>
@@ -7200,7 +7211,7 @@
           <p:cNvPr id="13" name="Rectangle 12">
             <a:extLst>
               <a:ext uri="{FF2B5EF4-FFF2-40B4-BE49-F238E27FC236}">
-                <a16:creationId xmlns:a16="http://schemas.microsoft.com/office/drawing/2014/main" id="{0612D428-3E8C-B6B9-EDE8-88974A9AC85B}"/>
+                <a16:creationId xmlns:a16="http://schemas.microsoft.com/office/drawing/2014/main" id="{88983B91-7162-A60C-7A53-0AB00D05CBA6}"/>
               </a:ext>
             </a:extLst>
           </p:cNvPr>
@@ -7268,7 +7279,7 @@
           <p:cNvPr id="14" name="TextBox 13">
             <a:extLst>
               <a:ext uri="{FF2B5EF4-FFF2-40B4-BE49-F238E27FC236}">
-                <a16:creationId xmlns:a16="http://schemas.microsoft.com/office/drawing/2014/main" id="{B62B9265-C60C-C0FE-A700-232C3EC8E65F}"/>
+                <a16:creationId xmlns:a16="http://schemas.microsoft.com/office/drawing/2014/main" id="{594DFFEF-58C8-080E-BB86-B6CE5C18D8C4}"/>
               </a:ext>
             </a:extLst>
           </p:cNvPr>
@@ -7347,7 +7358,7 @@
     </p:spTree>
     <p:extLst>
       <p:ext uri="{BB962C8B-B14F-4D97-AF65-F5344CB8AC3E}">
-        <p14:creationId xmlns:p14="http://schemas.microsoft.com/office/powerpoint/2010/main" val="1544808822"/>
+        <p14:creationId xmlns:p14="http://schemas.microsoft.com/office/powerpoint/2010/main" val="3267970226"/>
       </p:ext>
     </p:extLst>
   </p:cSld>
@@ -7379,7 +7390,7 @@
           <p:cNvPr id="2" name="Rectangle 1">
             <a:extLst>
               <a:ext uri="{FF2B5EF4-FFF2-40B4-BE49-F238E27FC236}">
-                <a16:creationId xmlns:a16="http://schemas.microsoft.com/office/drawing/2014/main" id="{60926A18-D6A9-9ECB-95F0-B48A731CE0A1}"/>
+                <a16:creationId xmlns:a16="http://schemas.microsoft.com/office/drawing/2014/main" id="{312A9B0C-56B5-6FFF-3924-F5647ED9A337}"/>
               </a:ext>
             </a:extLst>
           </p:cNvPr>
@@ -7447,7 +7458,7 @@
           <p:cNvPr id="3" name="TextBox 2">
             <a:extLst>
               <a:ext uri="{FF2B5EF4-FFF2-40B4-BE49-F238E27FC236}">
-                <a16:creationId xmlns:a16="http://schemas.microsoft.com/office/drawing/2014/main" id="{793BAB6C-ECF5-48A5-7510-22DCA93FF33F}"/>
+                <a16:creationId xmlns:a16="http://schemas.microsoft.com/office/drawing/2014/main" id="{401FA574-1E68-65EA-65C7-AA51A2EDBDEC}"/>
               </a:ext>
             </a:extLst>
           </p:cNvPr>
@@ -7487,7 +7498,7 @@
           <p:cNvPr id="4" name="Rectangle 3">
             <a:extLst>
               <a:ext uri="{FF2B5EF4-FFF2-40B4-BE49-F238E27FC236}">
-                <a16:creationId xmlns:a16="http://schemas.microsoft.com/office/drawing/2014/main" id="{0C7E7737-C354-2D5C-CD25-431F9645CB2A}"/>
+                <a16:creationId xmlns:a16="http://schemas.microsoft.com/office/drawing/2014/main" id="{C3BC1C9C-D9BD-B851-2AE5-1440F0DA57A9}"/>
               </a:ext>
             </a:extLst>
           </p:cNvPr>
@@ -7541,7 +7552,7 @@
           <p:cNvPr id="5" name="TextBox 4">
             <a:extLst>
               <a:ext uri="{FF2B5EF4-FFF2-40B4-BE49-F238E27FC236}">
-                <a16:creationId xmlns:a16="http://schemas.microsoft.com/office/drawing/2014/main" id="{74F6DDB8-AC57-5DA2-EB4C-041B6504A76E}"/>
+                <a16:creationId xmlns:a16="http://schemas.microsoft.com/office/drawing/2014/main" id="{DB2D72AE-FDE3-9C8D-70E9-9F7754328A86}"/>
               </a:ext>
             </a:extLst>
           </p:cNvPr>
@@ -7688,7 +7699,7 @@
           <p:cNvPr id="6" name="Rectangle 5">
             <a:extLst>
               <a:ext uri="{FF2B5EF4-FFF2-40B4-BE49-F238E27FC236}">
-                <a16:creationId xmlns:a16="http://schemas.microsoft.com/office/drawing/2014/main" id="{2642030D-0770-63EF-ECE9-F68A83865F49}"/>
+                <a16:creationId xmlns:a16="http://schemas.microsoft.com/office/drawing/2014/main" id="{1F9E02C7-BE8D-3B3D-9A70-8DEC6230A4A0}"/>
               </a:ext>
             </a:extLst>
           </p:cNvPr>
@@ -7742,7 +7753,7 @@
           <p:cNvPr id="7" name="TextBox 6">
             <a:extLst>
               <a:ext uri="{FF2B5EF4-FFF2-40B4-BE49-F238E27FC236}">
-                <a16:creationId xmlns:a16="http://schemas.microsoft.com/office/drawing/2014/main" id="{DB80008D-9A47-EEDE-48B9-EDDF3BBEB112}"/>
+                <a16:creationId xmlns:a16="http://schemas.microsoft.com/office/drawing/2014/main" id="{62880CC0-1ACA-3803-2283-92F48DB05B70}"/>
               </a:ext>
             </a:extLst>
           </p:cNvPr>
@@ -7834,7 +7845,7 @@
           <p:cNvPr id="8" name="Rectangle 7">
             <a:extLst>
               <a:ext uri="{FF2B5EF4-FFF2-40B4-BE49-F238E27FC236}">
-                <a16:creationId xmlns:a16="http://schemas.microsoft.com/office/drawing/2014/main" id="{3BE35F93-5B61-5F54-AD2B-9AF131CF1F42}"/>
+                <a16:creationId xmlns:a16="http://schemas.microsoft.com/office/drawing/2014/main" id="{A3F5D55A-F9E5-779C-E018-268D54CB6CCD}"/>
               </a:ext>
             </a:extLst>
           </p:cNvPr>
@@ -7888,7 +7899,7 @@
           <p:cNvPr id="9" name="TextBox 8">
             <a:extLst>
               <a:ext uri="{FF2B5EF4-FFF2-40B4-BE49-F238E27FC236}">
-                <a16:creationId xmlns:a16="http://schemas.microsoft.com/office/drawing/2014/main" id="{A6F428F7-FE19-A19D-7A03-77AF158BCF94}"/>
+                <a16:creationId xmlns:a16="http://schemas.microsoft.com/office/drawing/2014/main" id="{270965F5-3B92-8E43-9059-76C9476ED0ED}"/>
               </a:ext>
             </a:extLst>
           </p:cNvPr>
@@ -7991,7 +8002,7 @@
           <p:cNvPr id="10" name="Rectangle 9">
             <a:extLst>
               <a:ext uri="{FF2B5EF4-FFF2-40B4-BE49-F238E27FC236}">
-                <a16:creationId xmlns:a16="http://schemas.microsoft.com/office/drawing/2014/main" id="{5BDDF5E2-5BA7-0651-D89D-0D575BCA7B1A}"/>
+                <a16:creationId xmlns:a16="http://schemas.microsoft.com/office/drawing/2014/main" id="{73FBFEDA-5ECC-AA61-9EFF-BE3D6C44BB02}"/>
               </a:ext>
             </a:extLst>
           </p:cNvPr>
@@ -8045,7 +8056,7 @@
           <p:cNvPr id="11" name="TextBox 10">
             <a:extLst>
               <a:ext uri="{FF2B5EF4-FFF2-40B4-BE49-F238E27FC236}">
-                <a16:creationId xmlns:a16="http://schemas.microsoft.com/office/drawing/2014/main" id="{E3AC78F7-0525-FD60-735D-5E36ECDA09AB}"/>
+                <a16:creationId xmlns:a16="http://schemas.microsoft.com/office/drawing/2014/main" id="{AC2B01C7-4347-F1C3-67CD-A24ADA441D54}"/>
               </a:ext>
             </a:extLst>
           </p:cNvPr>
@@ -8157,7 +8168,7 @@
     </p:spTree>
     <p:extLst>
       <p:ext uri="{BB962C8B-B14F-4D97-AF65-F5344CB8AC3E}">
-        <p14:creationId xmlns:p14="http://schemas.microsoft.com/office/powerpoint/2010/main" val="2955353127"/>
+        <p14:creationId xmlns:p14="http://schemas.microsoft.com/office/powerpoint/2010/main" val="4218682080"/>
       </p:ext>
     </p:extLst>
   </p:cSld>
@@ -8189,7 +8200,7 @@
           <p:cNvPr id="2" name="Rectangle 1">
             <a:extLst>
               <a:ext uri="{FF2B5EF4-FFF2-40B4-BE49-F238E27FC236}">
-                <a16:creationId xmlns:a16="http://schemas.microsoft.com/office/drawing/2014/main" id="{532B98B5-D16D-74F0-73A9-83352192BF32}"/>
+                <a16:creationId xmlns:a16="http://schemas.microsoft.com/office/drawing/2014/main" id="{D65035BA-70C5-469F-F5A0-0719FFA1EC70}"/>
               </a:ext>
             </a:extLst>
           </p:cNvPr>
@@ -8257,7 +8268,7 @@
           <p:cNvPr id="3" name="TextBox 2">
             <a:extLst>
               <a:ext uri="{FF2B5EF4-FFF2-40B4-BE49-F238E27FC236}">
-                <a16:creationId xmlns:a16="http://schemas.microsoft.com/office/drawing/2014/main" id="{39F87E78-8C17-BBD9-EFD4-05522A90369F}"/>
+                <a16:creationId xmlns:a16="http://schemas.microsoft.com/office/drawing/2014/main" id="{2225228E-CC71-51B1-6A9F-BBEB8F0A3101}"/>
               </a:ext>
             </a:extLst>
           </p:cNvPr>
@@ -8297,7 +8308,7 @@
           <p:cNvPr id="4" name="Rectangle 3">
             <a:extLst>
               <a:ext uri="{FF2B5EF4-FFF2-40B4-BE49-F238E27FC236}">
-                <a16:creationId xmlns:a16="http://schemas.microsoft.com/office/drawing/2014/main" id="{D61DF2B6-6F40-C37D-1FF4-976D892ED93A}"/>
+                <a16:creationId xmlns:a16="http://schemas.microsoft.com/office/drawing/2014/main" id="{FCD03D83-FF02-9D96-3311-AD7AFB577E01}"/>
               </a:ext>
             </a:extLst>
           </p:cNvPr>
@@ -8351,7 +8362,7 @@
           <p:cNvPr id="5" name="TextBox 4">
             <a:extLst>
               <a:ext uri="{FF2B5EF4-FFF2-40B4-BE49-F238E27FC236}">
-                <a16:creationId xmlns:a16="http://schemas.microsoft.com/office/drawing/2014/main" id="{E947920B-26D6-B439-E222-8A1AAF699911}"/>
+                <a16:creationId xmlns:a16="http://schemas.microsoft.com/office/drawing/2014/main" id="{C3B35081-5206-8EAD-205D-C2B1EBCED9F0}"/>
               </a:ext>
             </a:extLst>
           </p:cNvPr>
@@ -8421,7 +8432,7 @@
           <p:cNvPr id="6" name="Rectangle 5">
             <a:extLst>
               <a:ext uri="{FF2B5EF4-FFF2-40B4-BE49-F238E27FC236}">
-                <a16:creationId xmlns:a16="http://schemas.microsoft.com/office/drawing/2014/main" id="{400D8C43-6715-4BDE-FB4D-FBC2BDFA093F}"/>
+                <a16:creationId xmlns:a16="http://schemas.microsoft.com/office/drawing/2014/main" id="{D0C3F391-A0FC-BABB-F490-B685219A2E12}"/>
               </a:ext>
             </a:extLst>
           </p:cNvPr>
@@ -8475,7 +8486,7 @@
           <p:cNvPr id="7" name="TextBox 6">
             <a:extLst>
               <a:ext uri="{FF2B5EF4-FFF2-40B4-BE49-F238E27FC236}">
-                <a16:creationId xmlns:a16="http://schemas.microsoft.com/office/drawing/2014/main" id="{BFB1E37C-ED46-0F65-3A37-099B2F323101}"/>
+                <a16:creationId xmlns:a16="http://schemas.microsoft.com/office/drawing/2014/main" id="{9CE3FFAA-9E92-9C55-5E20-1BEB623B4303}"/>
               </a:ext>
             </a:extLst>
           </p:cNvPr>
@@ -8534,7 +8545,7 @@
           <p:cNvPr id="8" name="Rectangle 7">
             <a:extLst>
               <a:ext uri="{FF2B5EF4-FFF2-40B4-BE49-F238E27FC236}">
-                <a16:creationId xmlns:a16="http://schemas.microsoft.com/office/drawing/2014/main" id="{3D1A2E28-11BC-481D-D8AA-D81351243E66}"/>
+                <a16:creationId xmlns:a16="http://schemas.microsoft.com/office/drawing/2014/main" id="{4C4AEF4A-BE86-B336-5720-16802616DF13}"/>
               </a:ext>
             </a:extLst>
           </p:cNvPr>
@@ -8588,7 +8599,7 @@
           <p:cNvPr id="9" name="TextBox 8">
             <a:extLst>
               <a:ext uri="{FF2B5EF4-FFF2-40B4-BE49-F238E27FC236}">
-                <a16:creationId xmlns:a16="http://schemas.microsoft.com/office/drawing/2014/main" id="{05E634CC-D937-8704-6F5D-5249352214BB}"/>
+                <a16:creationId xmlns:a16="http://schemas.microsoft.com/office/drawing/2014/main" id="{C378211D-3EF6-16AA-EC5B-2D2DC668834D}"/>
               </a:ext>
             </a:extLst>
           </p:cNvPr>
@@ -8647,7 +8658,7 @@
           <p:cNvPr id="10" name="Rectangle 9">
             <a:extLst>
               <a:ext uri="{FF2B5EF4-FFF2-40B4-BE49-F238E27FC236}">
-                <a16:creationId xmlns:a16="http://schemas.microsoft.com/office/drawing/2014/main" id="{3F3302CE-D8AA-937E-8876-EB5083C158B1}"/>
+                <a16:creationId xmlns:a16="http://schemas.microsoft.com/office/drawing/2014/main" id="{59C15576-5AED-71CD-4AC9-F25C363F0D85}"/>
               </a:ext>
             </a:extLst>
           </p:cNvPr>
@@ -8701,7 +8712,7 @@
           <p:cNvPr id="11" name="TextBox 10">
             <a:extLst>
               <a:ext uri="{FF2B5EF4-FFF2-40B4-BE49-F238E27FC236}">
-                <a16:creationId xmlns:a16="http://schemas.microsoft.com/office/drawing/2014/main" id="{3EC456A1-F3F2-3BDB-79CD-5654AB9F400B}"/>
+                <a16:creationId xmlns:a16="http://schemas.microsoft.com/office/drawing/2014/main" id="{2F7D39C6-6C82-78CA-E585-50A8D7A39720}"/>
               </a:ext>
             </a:extLst>
           </p:cNvPr>
@@ -8758,7 +8769,7 @@
     </p:spTree>
     <p:extLst>
       <p:ext uri="{BB962C8B-B14F-4D97-AF65-F5344CB8AC3E}">
-        <p14:creationId xmlns:p14="http://schemas.microsoft.com/office/powerpoint/2010/main" val="3993805748"/>
+        <p14:creationId xmlns:p14="http://schemas.microsoft.com/office/powerpoint/2010/main" val="1201551939"/>
       </p:ext>
     </p:extLst>
   </p:cSld>
@@ -8790,7 +8801,7 @@
           <p:cNvPr id="2" name="Rectangle 1">
             <a:extLst>
               <a:ext uri="{FF2B5EF4-FFF2-40B4-BE49-F238E27FC236}">
-                <a16:creationId xmlns:a16="http://schemas.microsoft.com/office/drawing/2014/main" id="{A7EE8461-1304-9084-4842-5AD8FE611810}"/>
+                <a16:creationId xmlns:a16="http://schemas.microsoft.com/office/drawing/2014/main" id="{D68485EB-2B32-2C46-3172-1694D16CCAFE}"/>
               </a:ext>
             </a:extLst>
           </p:cNvPr>
@@ -8858,7 +8869,7 @@
           <p:cNvPr id="3" name="TextBox 2">
             <a:extLst>
               <a:ext uri="{FF2B5EF4-FFF2-40B4-BE49-F238E27FC236}">
-                <a16:creationId xmlns:a16="http://schemas.microsoft.com/office/drawing/2014/main" id="{9C8A8D52-E7C2-0338-0EF0-D2860DAD23E9}"/>
+                <a16:creationId xmlns:a16="http://schemas.microsoft.com/office/drawing/2014/main" id="{09A3B1CB-C71A-5A23-AE35-DC0B61FB0A13}"/>
               </a:ext>
             </a:extLst>
           </p:cNvPr>
@@ -8898,7 +8909,7 @@
           <p:cNvPr id="4" name="Rectangle 3">
             <a:extLst>
               <a:ext uri="{FF2B5EF4-FFF2-40B4-BE49-F238E27FC236}">
-                <a16:creationId xmlns:a16="http://schemas.microsoft.com/office/drawing/2014/main" id="{2994F39C-2BF9-22F1-7551-2D1B498B748A}"/>
+                <a16:creationId xmlns:a16="http://schemas.microsoft.com/office/drawing/2014/main" id="{553FF5F9-F87A-D2BC-BB50-38FD7D6E34C2}"/>
               </a:ext>
             </a:extLst>
           </p:cNvPr>
@@ -8966,7 +8977,7 @@
           <p:cNvPr id="5" name="TextBox 4">
             <a:extLst>
               <a:ext uri="{FF2B5EF4-FFF2-40B4-BE49-F238E27FC236}">
-                <a16:creationId xmlns:a16="http://schemas.microsoft.com/office/drawing/2014/main" id="{B61617CC-EC85-F6AB-50D2-8E21F82E7497}"/>
+                <a16:creationId xmlns:a16="http://schemas.microsoft.com/office/drawing/2014/main" id="{A7B6D254-698C-0648-90FE-F32A3C6B8D7F}"/>
               </a:ext>
             </a:extLst>
           </p:cNvPr>
@@ -9126,7 +9137,7 @@
           <p:cNvPr id="6" name="Rectangle 5">
             <a:extLst>
               <a:ext uri="{FF2B5EF4-FFF2-40B4-BE49-F238E27FC236}">
-                <a16:creationId xmlns:a16="http://schemas.microsoft.com/office/drawing/2014/main" id="{42288F14-FFDA-716C-BDDE-67EB14162815}"/>
+                <a16:creationId xmlns:a16="http://schemas.microsoft.com/office/drawing/2014/main" id="{C95BA3C3-4746-4AF7-C497-0577B0F8D15C}"/>
               </a:ext>
             </a:extLst>
           </p:cNvPr>
@@ -9180,7 +9191,7 @@
           <p:cNvPr id="7" name="TextBox 6">
             <a:extLst>
               <a:ext uri="{FF2B5EF4-FFF2-40B4-BE49-F238E27FC236}">
-                <a16:creationId xmlns:a16="http://schemas.microsoft.com/office/drawing/2014/main" id="{2153EF22-C737-4B5F-8AAD-455745E3F158}"/>
+                <a16:creationId xmlns:a16="http://schemas.microsoft.com/office/drawing/2014/main" id="{8443692C-8430-5BDF-5D40-F4F974B8B58B}"/>
               </a:ext>
             </a:extLst>
           </p:cNvPr>
@@ -9343,7 +9354,7 @@
     </p:spTree>
     <p:extLst>
       <p:ext uri="{BB962C8B-B14F-4D97-AF65-F5344CB8AC3E}">
-        <p14:creationId xmlns:p14="http://schemas.microsoft.com/office/powerpoint/2010/main" val="480939956"/>
+        <p14:creationId xmlns:p14="http://schemas.microsoft.com/office/powerpoint/2010/main" val="3118305081"/>
       </p:ext>
     </p:extLst>
   </p:cSld>

</xml_diff>